<commit_message>
Add complete SETUP_GUIDE and wow owner presentation decks
- SETUP_GUIDE.md: end-to-end setup for dev, Docker, prod, env vars, every feature
- Expand .env.example with all aggregator and security variables
- Cross-link all docs from README, RESTAURANT_SETUP, AGGREGATOR_SETUP, PREMIUM_FEATURES
- Rebuild visual (18 slides) and detailed PPTX decks with KDS, takeaway, Swiggy/Zomato
- Enhanced build-visual-pptx.py and build-pptx.py with premium dark theme design
- Update presentation/README.md with regenerate instructions
</commit_message>
<xml_diff>
--- a/presentation/TableTap-Restaurant-Owner-Detailed-Deck.pptx
+++ b/presentation/TableTap-Restaurant-Owner-Detailed-Deck.pptx
@@ -20,6 +20,9 @@
     <p:sldId id="268" r:id="rId19"/>
     <p:sldId id="269" r:id="rId20"/>
     <p:sldId id="270" r:id="rId21"/>
+    <p:sldId id="271" r:id="rId22"/>
+    <p:sldId id="272" r:id="rId23"/>
+    <p:sldId id="273" r:id="rId24"/>
   </p:sldIdLst>
   <p:sldSz cx="12191695" cy="6858000" type="screen4x3"/>
   <p:notesSz cx="6858000" cy="9144000"/>
@@ -3098,7 +3101,7 @@
     <p:bg>
       <p:bgPr>
         <a:solidFill>
-          <a:srgbClr val="0F0F1A"/>
+          <a:srgbClr val="08080E"/>
         </a:solidFill>
         <a:effectLst/>
       </p:bgPr>
@@ -3119,7 +3122,7 @@
         <p:spPr>
           <a:xfrm>
             <a:off x="0" y="0"/>
-            <a:ext cx="12191695" cy="109728"/>
+            <a:ext cx="12191695" cy="73152"/>
           </a:xfrm>
           <a:prstGeom prst="rect">
             <a:avLst/>
@@ -3161,8 +3164,8 @@
         </p:nvSpPr>
         <p:spPr>
           <a:xfrm>
-            <a:off x="731520" y="1828800"/>
-            <a:ext cx="10515600" cy="2286000"/>
+            <a:off x="731520" y="1645920"/>
+            <a:ext cx="10515600" cy="2743200"/>
           </a:xfrm>
           <a:prstGeom prst="rect">
             <a:avLst/>
@@ -3176,7 +3179,7 @@
           <a:lstStyle/>
           <a:p>
             <a:pPr>
-              <a:defRPr sz="5400" b="1">
+              <a:defRPr sz="5600" b="1">
                 <a:solidFill>
                   <a:srgbClr val="F97316"/>
                 </a:solidFill>
@@ -3198,13 +3201,13 @@
               </a:defRPr>
             </a:pPr>
             <a:r>
-              <a:t>Smart QR Ordering for Restaurants</a:t>
+              <a:t>Complete Restaurant Operating System</a:t>
             </a:r>
           </a:p>
           <a:p>
             <a:pPr>
               <a:spcBef>
-                <a:spcPts val="2000"/>
+                <a:spcPts val="1800"/>
               </a:spcBef>
               <a:defRPr sz="1800">
                 <a:solidFill>
@@ -3213,7 +3216,7 @@
               </a:defRPr>
             </a:pPr>
             <a:r>
-              <a:t>Scan · Order · Enjoy — less waiting, less waste, happier guests</a:t>
+              <a:t>QR dining · Kitchen · Payments · Takeaway · Swiggy/Zomato — one platform</a:t>
             </a:r>
           </a:p>
         </p:txBody>
@@ -3248,7 +3251,7 @@
               </a:defRPr>
             </a:pPr>
             <a:r>
-              <a:t>Owner presentation · Demo: Varanasi Restaurant</a:t>
+              <a:t>TableTap · Complete Restaurant Platform</a:t>
             </a:r>
           </a:p>
         </p:txBody>
@@ -3267,7 +3270,7 @@
     <p:bg>
       <p:bgPr>
         <a:solidFill>
-          <a:srgbClr val="0F0F1A"/>
+          <a:srgbClr val="08080E"/>
         </a:solidFill>
         <a:effectLst/>
       </p:bgPr>
@@ -3281,7 +3284,50 @@
       <p:grpSpPr/>
       <p:sp>
         <p:nvSpPr>
-          <p:cNvPr id="2" name="TextBox 1"/>
+          <p:cNvPr id="2" name="Rectangle 1"/>
+          <p:cNvSpPr/>
+          <p:nvPr/>
+        </p:nvSpPr>
+        <p:spPr>
+          <a:xfrm>
+            <a:off x="0" y="0"/>
+            <a:ext cx="12191695" cy="73152"/>
+          </a:xfrm>
+          <a:prstGeom prst="rect">
+            <a:avLst/>
+          </a:prstGeom>
+          <a:solidFill>
+            <a:srgbClr val="F97316"/>
+          </a:solidFill>
+          <a:ln>
+            <a:noFill/>
+          </a:ln>
+        </p:spPr>
+        <p:style>
+          <a:lnRef idx="1">
+            <a:schemeClr val="accent1"/>
+          </a:lnRef>
+          <a:fillRef idx="3">
+            <a:schemeClr val="accent1"/>
+          </a:fillRef>
+          <a:effectRef idx="2">
+            <a:schemeClr val="accent1"/>
+          </a:effectRef>
+          <a:fontRef idx="minor">
+            <a:schemeClr val="lt1"/>
+          </a:fontRef>
+        </p:style>
+        <p:txBody>
+          <a:bodyPr rtlCol="0" anchor="ctr"/>
+          <a:lstStyle/>
+          <a:p>
+            <a:pPr algn="ctr"/>
+          </a:p>
+        </p:txBody>
+      </p:sp>
+      <p:sp>
+        <p:nvSpPr>
+          <p:cNvPr id="3" name="TextBox 2"/>
           <p:cNvSpPr txBox="1"/>
           <p:nvPr/>
         </p:nvSpPr>
@@ -3309,7 +3355,7 @@
               </a:defRPr>
             </a:pPr>
             <a:r>
-              <a:t>Menu management</a:t>
+              <a:t>Swiggy &amp; Zomato integration</a:t>
             </a:r>
           </a:p>
           <a:p>
@@ -3324,38 +3370,265 @@
               </a:defRPr>
             </a:pPr>
             <a:r>
-              <a:t>Update prices &amp; availability anytime</a:t>
-            </a:r>
-          </a:p>
-        </p:txBody>
-      </p:sp>
-      <p:pic>
-        <p:nvPicPr>
-          <p:cNvPr id="3" name="Picture 2" descr="08-admin-menu.png"/>
-          <p:cNvPicPr>
-            <a:picLocks noChangeAspect="1"/>
-          </p:cNvPicPr>
-          <p:nvPr/>
-        </p:nvPicPr>
-        <p:blipFill>
-          <a:blip r:embed="rId2"/>
-          <a:stretch>
-            <a:fillRect/>
-          </a:stretch>
-        </p:blipFill>
-        <p:spPr>
-          <a:xfrm>
-            <a:off x="731520" y="1143000"/>
-            <a:ext cx="10789920" cy="6743700"/>
-          </a:xfrm>
-          <a:prstGeom prst="rect">
-            <a:avLst/>
-          </a:prstGeom>
-        </p:spPr>
-      </p:pic>
+              <a:t>Premium aggregator_inbox — automatic ready mode</a:t>
+            </a:r>
+          </a:p>
+        </p:txBody>
+      </p:sp>
       <p:sp>
         <p:nvSpPr>
           <p:cNvPr id="4" name="TextBox 3"/>
+          <p:cNvSpPr txBox="1"/>
+          <p:nvPr/>
+        </p:nvSpPr>
+        <p:spPr>
+          <a:xfrm>
+            <a:off x="640080" y="1463040"/>
+            <a:ext cx="5669280" cy="4572000"/>
+          </a:xfrm>
+          <a:prstGeom prst="rect">
+            <a:avLst/>
+          </a:prstGeom>
+          <a:noFill/>
+        </p:spPr>
+        <p:txBody>
+          <a:bodyPr wrap="square">
+            <a:spAutoFit/>
+          </a:bodyPr>
+          <a:lstStyle/>
+          <a:p>
+            <a:pPr>
+              <a:spcAft>
+                <a:spcPts val="800"/>
+              </a:spcAft>
+              <a:defRPr sz="1700">
+                <a:solidFill>
+                  <a:srgbClr val="FFFFFF"/>
+                </a:solidFill>
+              </a:defRPr>
+            </a:pPr>
+            <a:r>
+              <a:t>Owner saves outlet ID + API key in Admin → Integrations</a:t>
+            </a:r>
+          </a:p>
+          <a:p>
+            <a:pPr>
+              <a:spcAft>
+                <a:spcPts val="800"/>
+              </a:spcAft>
+              <a:defRPr sz="1700">
+                <a:solidFill>
+                  <a:srgbClr val="FFFFFF"/>
+                </a:solidFill>
+              </a:defRPr>
+            </a:pPr>
+            <a:r>
+              <a:t>TableTap generates webhook URL + secret</a:t>
+            </a:r>
+          </a:p>
+          <a:p>
+            <a:pPr>
+              <a:spcAft>
+                <a:spcPts val="800"/>
+              </a:spcAft>
+              <a:defRPr sz="1700">
+                <a:solidFill>
+                  <a:srgbClr val="FFFFFF"/>
+                </a:solidFill>
+              </a:defRPr>
+            </a:pPr>
+            <a:r>
+              <a:t>Partner team activates webhook (one-time)</a:t>
+            </a:r>
+          </a:p>
+          <a:p>
+            <a:pPr>
+              <a:spcAft>
+                <a:spcPts val="800"/>
+              </a:spcAft>
+              <a:defRPr sz="1700">
+                <a:solidFill>
+                  <a:srgbClr val="FFFFFF"/>
+                </a:solidFill>
+              </a:defRPr>
+            </a:pPr>
+            <a:r>
+              <a:t>Orders appear on kitchen board — no manual entry</a:t>
+            </a:r>
+          </a:p>
+          <a:p>
+            <a:pPr>
+              <a:spcAft>
+                <a:spcPts val="800"/>
+              </a:spcAft>
+              <a:defRPr sz="1700">
+                <a:solidFill>
+                  <a:srgbClr val="FFFFFF"/>
+                </a:solidFill>
+              </a:defRPr>
+            </a:pPr>
+            <a:r>
+              <a:t>Menu syncs outbound when prices/stock change</a:t>
+            </a:r>
+          </a:p>
+          <a:p>
+            <a:pPr>
+              <a:spcAft>
+                <a:spcPts val="800"/>
+              </a:spcAft>
+              <a:defRPr sz="1700">
+                <a:solidFill>
+                  <a:srgbClr val="FFFFFF"/>
+                </a:solidFill>
+              </a:defRPr>
+            </a:pPr>
+            <a:r>
+              <a:t>Ready / picked up / delivered pushed back to platform</a:t>
+            </a:r>
+          </a:p>
+        </p:txBody>
+      </p:sp>
+      <p:sp>
+        <p:nvSpPr>
+          <p:cNvPr id="5" name="Rounded Rectangle 4"/>
+          <p:cNvSpPr/>
+          <p:nvPr/>
+        </p:nvSpPr>
+        <p:spPr>
+          <a:xfrm>
+            <a:off x="6583680" y="1371600"/>
+            <a:ext cx="4572000" cy="1828800"/>
+          </a:xfrm>
+          <a:prstGeom prst="roundRect">
+            <a:avLst/>
+          </a:prstGeom>
+          <a:solidFill>
+            <a:srgbClr val="161622"/>
+          </a:solidFill>
+          <a:ln>
+            <a:solidFill>
+              <a:srgbClr val="373748"/>
+            </a:solidFill>
+          </a:ln>
+        </p:spPr>
+        <p:style>
+          <a:lnRef idx="1">
+            <a:schemeClr val="accent1"/>
+          </a:lnRef>
+          <a:fillRef idx="3">
+            <a:schemeClr val="accent1"/>
+          </a:fillRef>
+          <a:effectRef idx="2">
+            <a:schemeClr val="accent1"/>
+          </a:effectRef>
+          <a:fontRef idx="minor">
+            <a:schemeClr val="lt1"/>
+          </a:fontRef>
+        </p:style>
+        <p:txBody>
+          <a:bodyPr rtlCol="0" anchor="ctr" lIns="137160"/>
+          <a:lstStyle/>
+          <a:p>
+            <a:pPr algn="ctr">
+              <a:defRPr sz="1600" b="1">
+                <a:solidFill>
+                  <a:srgbClr val="FFFFFF"/>
+                </a:solidFill>
+              </a:defRPr>
+            </a:pPr>
+            <a:r>
+              <a:t>Full loop</a:t>
+            </a:r>
+          </a:p>
+          <a:p>
+            <a:pPr>
+              <a:spcBef>
+                <a:spcPts val="600"/>
+              </a:spcBef>
+              <a:defRPr sz="1100">
+                <a:solidFill>
+                  <a:srgbClr val="A1A1AA"/>
+                </a:solidFill>
+              </a:defRPr>
+            </a:pPr>
+            <a:r>
+              <a:t>Ingest → confirm → prepare → ready → picked up. See AGGREGATOR_SETUP.md</a:t>
+            </a:r>
+          </a:p>
+        </p:txBody>
+      </p:sp>
+      <p:sp>
+        <p:nvSpPr>
+          <p:cNvPr id="6" name="Rounded Rectangle 5"/>
+          <p:cNvSpPr/>
+          <p:nvPr/>
+        </p:nvSpPr>
+        <p:spPr>
+          <a:xfrm>
+            <a:off x="6583680" y="3474720"/>
+            <a:ext cx="4572000" cy="1097280"/>
+          </a:xfrm>
+          <a:prstGeom prst="roundRect">
+            <a:avLst/>
+          </a:prstGeom>
+          <a:solidFill>
+            <a:srgbClr val="161622"/>
+          </a:solidFill>
+          <a:ln>
+            <a:solidFill>
+              <a:srgbClr val="373748"/>
+            </a:solidFill>
+          </a:ln>
+        </p:spPr>
+        <p:style>
+          <a:lnRef idx="1">
+            <a:schemeClr val="accent1"/>
+          </a:lnRef>
+          <a:fillRef idx="3">
+            <a:schemeClr val="accent1"/>
+          </a:fillRef>
+          <a:effectRef idx="2">
+            <a:schemeClr val="accent1"/>
+          </a:effectRef>
+          <a:fontRef idx="minor">
+            <a:schemeClr val="lt1"/>
+          </a:fontRef>
+        </p:style>
+        <p:txBody>
+          <a:bodyPr rtlCol="0" anchor="ctr" lIns="137160"/>
+          <a:lstStyle/>
+          <a:p>
+            <a:pPr algn="ctr">
+              <a:defRPr sz="1600" b="1">
+                <a:solidFill>
+                  <a:srgbClr val="FFFFFF"/>
+                </a:solidFill>
+              </a:defRPr>
+            </a:pPr>
+            <a:r>
+              <a:t>Menu mapping</a:t>
+            </a:r>
+          </a:p>
+          <a:p>
+            <a:pPr>
+              <a:spcBef>
+                <a:spcPts val="600"/>
+              </a:spcBef>
+              <a:defRPr sz="1100">
+                <a:solidFill>
+                  <a:srgbClr val="A1A1AA"/>
+                </a:solidFill>
+              </a:defRPr>
+            </a:pPr>
+            <a:r>
+              <a:t>Set swiggyItemId / zomatoItemId or match names</a:t>
+            </a:r>
+          </a:p>
+        </p:txBody>
+      </p:sp>
+      <p:sp>
+        <p:nvSpPr>
+          <p:cNvPr id="7" name="TextBox 6"/>
           <p:cNvSpPr txBox="1"/>
           <p:nvPr/>
         </p:nvSpPr>
@@ -3383,7 +3656,7 @@
               </a:defRPr>
             </a:pPr>
             <a:r>
-              <a:t>TableTap · Smart Restaurant Ordering</a:t>
+              <a:t>TableTap · Complete Restaurant Platform</a:t>
             </a:r>
           </a:p>
         </p:txBody>
@@ -3402,7 +3675,7 @@
     <p:bg>
       <p:bgPr>
         <a:solidFill>
-          <a:srgbClr val="0F0F1A"/>
+          <a:srgbClr val="08080E"/>
         </a:solidFill>
         <a:effectLst/>
       </p:bgPr>
@@ -3416,7 +3689,50 @@
       <p:grpSpPr/>
       <p:sp>
         <p:nvSpPr>
-          <p:cNvPr id="2" name="TextBox 1"/>
+          <p:cNvPr id="2" name="Rectangle 1"/>
+          <p:cNvSpPr/>
+          <p:nvPr/>
+        </p:nvSpPr>
+        <p:spPr>
+          <a:xfrm>
+            <a:off x="0" y="0"/>
+            <a:ext cx="12191695" cy="73152"/>
+          </a:xfrm>
+          <a:prstGeom prst="rect">
+            <a:avLst/>
+          </a:prstGeom>
+          <a:solidFill>
+            <a:srgbClr val="F97316"/>
+          </a:solidFill>
+          <a:ln>
+            <a:noFill/>
+          </a:ln>
+        </p:spPr>
+        <p:style>
+          <a:lnRef idx="1">
+            <a:schemeClr val="accent1"/>
+          </a:lnRef>
+          <a:fillRef idx="3">
+            <a:schemeClr val="accent1"/>
+          </a:fillRef>
+          <a:effectRef idx="2">
+            <a:schemeClr val="accent1"/>
+          </a:effectRef>
+          <a:fontRef idx="minor">
+            <a:schemeClr val="lt1"/>
+          </a:fontRef>
+        </p:style>
+        <p:txBody>
+          <a:bodyPr rtlCol="0" anchor="ctr"/>
+          <a:lstStyle/>
+          <a:p>
+            <a:pPr algn="ctr"/>
+          </a:p>
+        </p:txBody>
+      </p:sp>
+      <p:sp>
+        <p:nvSpPr>
+          <p:cNvPr id="3" name="TextBox 2"/>
           <p:cNvSpPr txBox="1"/>
           <p:nvPr/>
         </p:nvSpPr>
@@ -3444,7 +3760,7 @@
               </a:defRPr>
             </a:pPr>
             <a:r>
-              <a:t>Reports &amp; insights</a:t>
+              <a:t>Owner admin tools</a:t>
             </a:r>
           </a:p>
           <a:p>
@@ -3459,14 +3775,14 @@
               </a:defRPr>
             </a:pPr>
             <a:r>
-              <a:t>Daily revenue and order analytics</a:t>
+              <a:t>Menu · QR · Reports · Integrations</a:t>
             </a:r>
           </a:p>
         </p:txBody>
       </p:sp>
       <p:pic>
         <p:nvPicPr>
-          <p:cNvPr id="3" name="Picture 2" descr="09-admin-reports.png"/>
+          <p:cNvPr id="4" name="Picture 3" descr="07-admin-qr-codes.png"/>
           <p:cNvPicPr>
             <a:picLocks noChangeAspect="1"/>
           </p:cNvPicPr>
@@ -3481,16 +3797,40 @@
         <p:spPr>
           <a:xfrm>
             <a:off x="731520" y="1143000"/>
-            <a:ext cx="10789920" cy="6743700"/>
+            <a:ext cx="5303520" cy="3314700"/>
           </a:xfrm>
           <a:prstGeom prst="rect">
             <a:avLst/>
           </a:prstGeom>
         </p:spPr>
       </p:pic>
-      <p:sp>
-        <p:nvSpPr>
-          <p:cNvPr id="4" name="TextBox 3"/>
+      <p:pic>
+        <p:nvPicPr>
+          <p:cNvPr id="5" name="Picture 4" descr="08-admin-menu.png"/>
+          <p:cNvPicPr>
+            <a:picLocks noChangeAspect="1"/>
+          </p:cNvPicPr>
+          <p:nvPr/>
+        </p:nvPicPr>
+        <p:blipFill>
+          <a:blip r:embed="rId3"/>
+          <a:stretch>
+            <a:fillRect/>
+          </a:stretch>
+        </p:blipFill>
+        <p:spPr>
+          <a:xfrm>
+            <a:off x="6263640" y="1143000"/>
+            <a:ext cx="5303520" cy="3314700"/>
+          </a:xfrm>
+          <a:prstGeom prst="rect">
+            <a:avLst/>
+          </a:prstGeom>
+        </p:spPr>
+      </p:pic>
+      <p:sp>
+        <p:nvSpPr>
+          <p:cNvPr id="6" name="TextBox 5"/>
           <p:cNvSpPr txBox="1"/>
           <p:nvPr/>
         </p:nvSpPr>
@@ -3518,7 +3858,7 @@
               </a:defRPr>
             </a:pPr>
             <a:r>
-              <a:t>TableTap · Smart Restaurant Ordering</a:t>
+              <a:t>TableTap · Complete Restaurant Platform</a:t>
             </a:r>
           </a:p>
         </p:txBody>
@@ -3537,7 +3877,7 @@
     <p:bg>
       <p:bgPr>
         <a:solidFill>
-          <a:srgbClr val="0F0F1A"/>
+          <a:srgbClr val="08080E"/>
         </a:solidFill>
         <a:effectLst/>
       </p:bgPr>
@@ -3551,7 +3891,50 @@
       <p:grpSpPr/>
       <p:sp>
         <p:nvSpPr>
-          <p:cNvPr id="2" name="TextBox 1"/>
+          <p:cNvPr id="2" name="Rectangle 1"/>
+          <p:cNvSpPr/>
+          <p:nvPr/>
+        </p:nvSpPr>
+        <p:spPr>
+          <a:xfrm>
+            <a:off x="0" y="0"/>
+            <a:ext cx="12191695" cy="73152"/>
+          </a:xfrm>
+          <a:prstGeom prst="rect">
+            <a:avLst/>
+          </a:prstGeom>
+          <a:solidFill>
+            <a:srgbClr val="F97316"/>
+          </a:solidFill>
+          <a:ln>
+            <a:noFill/>
+          </a:ln>
+        </p:spPr>
+        <p:style>
+          <a:lnRef idx="1">
+            <a:schemeClr val="accent1"/>
+          </a:lnRef>
+          <a:fillRef idx="3">
+            <a:schemeClr val="accent1"/>
+          </a:fillRef>
+          <a:effectRef idx="2">
+            <a:schemeClr val="accent1"/>
+          </a:effectRef>
+          <a:fontRef idx="minor">
+            <a:schemeClr val="lt1"/>
+          </a:fontRef>
+        </p:style>
+        <p:txBody>
+          <a:bodyPr rtlCol="0" anchor="ctr"/>
+          <a:lstStyle/>
+          <a:p>
+            <a:pPr algn="ctr"/>
+          </a:p>
+        </p:txBody>
+      </p:sp>
+      <p:sp>
+        <p:nvSpPr>
+          <p:cNvPr id="3" name="TextBox 2"/>
           <p:cNvSpPr txBox="1"/>
           <p:nvPr/>
         </p:nvSpPr>
@@ -3579,7 +3962,7 @@
               </a:defRPr>
             </a:pPr>
             <a:r>
-              <a:t>Role-based permissions</a:t>
+              <a:t>Reports &amp; team performance</a:t>
             </a:r>
           </a:p>
           <a:p>
@@ -3594,97 +3977,38 @@
               </a:defRPr>
             </a:pPr>
             <a:r>
-              <a:t>Right access for each team member</a:t>
-            </a:r>
-          </a:p>
-        </p:txBody>
-      </p:sp>
-      <p:sp>
-        <p:nvSpPr>
-          <p:cNvPr id="3" name="TextBox 2"/>
-          <p:cNvSpPr txBox="1"/>
-          <p:nvPr/>
-        </p:nvSpPr>
-        <p:spPr>
-          <a:xfrm>
-            <a:off x="640080" y="1463040"/>
-            <a:ext cx="5303520" cy="4572000"/>
-          </a:xfrm>
-          <a:prstGeom prst="rect">
-            <a:avLst/>
-          </a:prstGeom>
-          <a:noFill/>
-        </p:spPr>
-        <p:txBody>
-          <a:bodyPr wrap="square">
-            <a:spAutoFit/>
-          </a:bodyPr>
-          <a:lstStyle/>
-          <a:p>
-            <a:pPr>
-              <a:spcAft>
-                <a:spcPts val="1000"/>
-              </a:spcAft>
-              <a:defRPr sz="1800">
-                <a:solidFill>
-                  <a:srgbClr val="FFFFFF"/>
-                </a:solidFill>
-              </a:defRPr>
-            </a:pPr>
-            <a:r>
-              <a:t>Owner / Manager — full dashboard, menu, QR, reports, payments</a:t>
-            </a:r>
-          </a:p>
-          <a:p>
-            <a:pPr>
-              <a:spcAft>
-                <a:spcPts val="1000"/>
-              </a:spcAft>
-              <a:defRPr sz="1800">
-                <a:solidFill>
-                  <a:srgbClr val="FFFFFF"/>
-                </a:solidFill>
-              </a:defRPr>
-            </a:pPr>
-            <a:r>
-              <a:t>Cook — prepare items, mark unavailable, view overdue</a:t>
-            </a:r>
-          </a:p>
-          <a:p>
-            <a:pPr>
-              <a:spcAft>
-                <a:spcPts val="1000"/>
-              </a:spcAft>
-              <a:defRPr sz="1800">
-                <a:solidFill>
-                  <a:srgbClr val="FFFFFF"/>
-                </a:solidFill>
-              </a:defRPr>
-            </a:pPr>
-            <a:r>
-              <a:t>Server — serve items, collect payment, open tables</a:t>
-            </a:r>
-          </a:p>
-          <a:p>
-            <a:pPr>
-              <a:spcAft>
-                <a:spcPts val="1000"/>
-              </a:spcAft>
-              <a:defRPr sz="1800">
-                <a:solidFill>
-                  <a:srgbClr val="FFFFFF"/>
-                </a:solidFill>
-              </a:defRPr>
-            </a:pPr>
-            <a:r>
-              <a:t>Platform admin — configure staff slots &amp; export credentials</a:t>
-            </a:r>
-          </a:p>
-        </p:txBody>
-      </p:sp>
-      <p:sp>
-        <p:nvSpPr>
-          <p:cNvPr id="4" name="TextBox 3"/>
+              <a:t>Daily CSV + accountability</a:t>
+            </a:r>
+          </a:p>
+        </p:txBody>
+      </p:sp>
+      <p:pic>
+        <p:nvPicPr>
+          <p:cNvPr id="4" name="Picture 3" descr="09-admin-reports.png"/>
+          <p:cNvPicPr>
+            <a:picLocks noChangeAspect="1"/>
+          </p:cNvPicPr>
+          <p:nvPr/>
+        </p:nvPicPr>
+        <p:blipFill>
+          <a:blip r:embed="rId2"/>
+          <a:stretch>
+            <a:fillRect/>
+          </a:stretch>
+        </p:blipFill>
+        <p:spPr>
+          <a:xfrm>
+            <a:off x="731520" y="1143000"/>
+            <a:ext cx="10789920" cy="6743700"/>
+          </a:xfrm>
+          <a:prstGeom prst="rect">
+            <a:avLst/>
+          </a:prstGeom>
+        </p:spPr>
+      </p:pic>
+      <p:sp>
+        <p:nvSpPr>
+          <p:cNvPr id="5" name="TextBox 4"/>
           <p:cNvSpPr txBox="1"/>
           <p:nvPr/>
         </p:nvSpPr>
@@ -3712,7 +4036,7 @@
               </a:defRPr>
             </a:pPr>
             <a:r>
-              <a:t>TableTap · Smart Restaurant Ordering</a:t>
+              <a:t>TableTap · Complete Restaurant Platform</a:t>
             </a:r>
           </a:p>
         </p:txBody>
@@ -3731,7 +4055,7 @@
     <p:bg>
       <p:bgPr>
         <a:solidFill>
-          <a:srgbClr val="0F0F1A"/>
+          <a:srgbClr val="08080E"/>
         </a:solidFill>
         <a:effectLst/>
       </p:bgPr>
@@ -3745,7 +4069,50 @@
       <p:grpSpPr/>
       <p:sp>
         <p:nvSpPr>
-          <p:cNvPr id="2" name="TextBox 1"/>
+          <p:cNvPr id="2" name="Rectangle 1"/>
+          <p:cNvSpPr/>
+          <p:nvPr/>
+        </p:nvSpPr>
+        <p:spPr>
+          <a:xfrm>
+            <a:off x="0" y="0"/>
+            <a:ext cx="12191695" cy="73152"/>
+          </a:xfrm>
+          <a:prstGeom prst="rect">
+            <a:avLst/>
+          </a:prstGeom>
+          <a:solidFill>
+            <a:srgbClr val="F97316"/>
+          </a:solidFill>
+          <a:ln>
+            <a:noFill/>
+          </a:ln>
+        </p:spPr>
+        <p:style>
+          <a:lnRef idx="1">
+            <a:schemeClr val="accent1"/>
+          </a:lnRef>
+          <a:fillRef idx="3">
+            <a:schemeClr val="accent1"/>
+          </a:fillRef>
+          <a:effectRef idx="2">
+            <a:schemeClr val="accent1"/>
+          </a:effectRef>
+          <a:fontRef idx="minor">
+            <a:schemeClr val="lt1"/>
+          </a:fontRef>
+        </p:style>
+        <p:txBody>
+          <a:bodyPr rtlCol="0" anchor="ctr"/>
+          <a:lstStyle/>
+          <a:p>
+            <a:pPr algn="ctr"/>
+          </a:p>
+        </p:txBody>
+      </p:sp>
+      <p:sp>
+        <p:nvSpPr>
+          <p:cNvPr id="3" name="TextBox 2"/>
           <p:cNvSpPr txBox="1"/>
           <p:nvPr/>
         </p:nvSpPr>
@@ -3773,7 +4140,7 @@
               </a:defRPr>
             </a:pPr>
             <a:r>
-              <a:t>Benefits for restaurant owners</a:t>
+              <a:t>Core vs Premium</a:t>
             </a:r>
           </a:p>
           <a:p>
@@ -3788,21 +4155,104 @@
               </a:defRPr>
             </a:pPr>
             <a:r>
-              <a:t>Why TableTap pays for itself</a:t>
-            </a:r>
-          </a:p>
-        </p:txBody>
-      </p:sp>
-      <p:sp>
-        <p:nvSpPr>
-          <p:cNvPr id="3" name="TextBox 2"/>
+              <a:t>Flexible tiers — toggle live without downtime</a:t>
+            </a:r>
+          </a:p>
+        </p:txBody>
+      </p:sp>
+      <p:sp>
+        <p:nvSpPr>
+          <p:cNvPr id="4" name="TextBox 3"/>
           <p:cNvSpPr txBox="1"/>
           <p:nvPr/>
         </p:nvSpPr>
         <p:spPr>
           <a:xfrm>
-            <a:off x="731520" y="1371600"/>
-            <a:ext cx="10515600" cy="640080"/>
+            <a:off x="640080" y="1371600"/>
+            <a:ext cx="10515600" cy="4572000"/>
+          </a:xfrm>
+          <a:prstGeom prst="rect">
+            <a:avLst/>
+          </a:prstGeom>
+          <a:noFill/>
+        </p:spPr>
+        <p:txBody>
+          <a:bodyPr wrap="square">
+            <a:spAutoFit/>
+          </a:bodyPr>
+          <a:lstStyle/>
+          <a:p>
+            <a:pPr>
+              <a:spcAft>
+                <a:spcPts val="800"/>
+              </a:spcAft>
+              <a:defRPr sz="1700">
+                <a:solidFill>
+                  <a:srgbClr val="FFFFFF"/>
+                </a:solidFill>
+              </a:defRPr>
+            </a:pPr>
+            <a:r>
+              <a:t>CORE: QR ordering, staff dashboard, menu, payments, PhonePe QR, sessions, rewards, reports</a:t>
+            </a:r>
+          </a:p>
+          <a:p>
+            <a:pPr>
+              <a:spcAft>
+                <a:spcPts val="800"/>
+              </a:spcAft>
+              <a:defRPr sz="1700">
+                <a:solidFill>
+                  <a:srgbClr val="FFFFFF"/>
+                </a:solidFill>
+              </a:defRPr>
+            </a:pPr>
+            <a:r>
+              <a:t>PREMIUM: KDS, floor plan, split bill, thermal receipts, phone orders, GST, aggregator sync, staff performance</a:t>
+            </a:r>
+          </a:p>
+          <a:p>
+            <a:pPr>
+              <a:spcAft>
+                <a:spcPts val="800"/>
+              </a:spcAft>
+              <a:defRPr sz="1700">
+                <a:solidFill>
+                  <a:srgbClr val="FFFFFF"/>
+                </a:solidFill>
+              </a:defRPr>
+            </a:pPr>
+            <a:r>
+              <a:t>Super admin at /platform/login — hidden from restaurant owners</a:t>
+            </a:r>
+          </a:p>
+          <a:p>
+            <a:pPr>
+              <a:spcAft>
+                <a:spcPts val="800"/>
+              </a:spcAft>
+              <a:defRPr sz="1700">
+                <a:solidFill>
+                  <a:srgbClr val="FFFFFF"/>
+                </a:solidFill>
+              </a:defRPr>
+            </a:pPr>
+            <a:r>
+              <a:t>Enable via CLI: npx tsx scripts/enable-premium-features.ts --slug SLUG --all</a:t>
+            </a:r>
+          </a:p>
+        </p:txBody>
+      </p:sp>
+      <p:sp>
+        <p:nvSpPr>
+          <p:cNvPr id="5" name="TextBox 4"/>
+          <p:cNvSpPr txBox="1"/>
+          <p:nvPr/>
+        </p:nvSpPr>
+        <p:spPr>
+          <a:xfrm>
+            <a:off x="548640" y="6400800"/>
+            <a:ext cx="10972800" cy="365760"/>
           </a:xfrm>
           <a:prstGeom prst="rect">
             <a:avLst/>
@@ -3815,252 +4265,6 @@
           </a:bodyPr>
           <a:lstStyle/>
           <a:p>
-            <a:r>
-              <a:rPr b="1" sz="1800">
-                <a:solidFill>
-                  <a:srgbClr val="34D399"/>
-                </a:solidFill>
-              </a:rPr>
-              <a:t>✓  Faster service — </a:t>
-            </a:r>
-            <a:r>
-              <a:rPr sz="1800">
-                <a:solidFill>
-                  <a:srgbClr val="FFFFFF"/>
-                </a:solidFill>
-              </a:rPr>
-              <a:t>Guests order without waiting for staff</a:t>
-            </a:r>
-          </a:p>
-        </p:txBody>
-      </p:sp>
-      <p:sp>
-        <p:nvSpPr>
-          <p:cNvPr id="4" name="TextBox 3"/>
-          <p:cNvSpPr txBox="1"/>
-          <p:nvPr/>
-        </p:nvSpPr>
-        <p:spPr>
-          <a:xfrm>
-            <a:off x="731520" y="2057400"/>
-            <a:ext cx="10515600" cy="640080"/>
-          </a:xfrm>
-          <a:prstGeom prst="rect">
-            <a:avLst/>
-          </a:prstGeom>
-          <a:noFill/>
-        </p:spPr>
-        <p:txBody>
-          <a:bodyPr wrap="none">
-            <a:spAutoFit/>
-          </a:bodyPr>
-          <a:lstStyle/>
-          <a:p>
-            <a:r>
-              <a:rPr b="1" sz="1800">
-                <a:solidFill>
-                  <a:srgbClr val="34D399"/>
-                </a:solidFill>
-              </a:rPr>
-              <a:t>✓  Less error — </a:t>
-            </a:r>
-            <a:r>
-              <a:rPr sz="1800">
-                <a:solidFill>
-                  <a:srgbClr val="FFFFFF"/>
-                </a:solidFill>
-              </a:rPr>
-              <a:t>Digital orders go straight to the kitchen</a:t>
-            </a:r>
-          </a:p>
-        </p:txBody>
-      </p:sp>
-      <p:sp>
-        <p:nvSpPr>
-          <p:cNvPr id="5" name="TextBox 4"/>
-          <p:cNvSpPr txBox="1"/>
-          <p:nvPr/>
-        </p:nvSpPr>
-        <p:spPr>
-          <a:xfrm>
-            <a:off x="731520" y="2743200"/>
-            <a:ext cx="10515600" cy="640080"/>
-          </a:xfrm>
-          <a:prstGeom prst="rect">
-            <a:avLst/>
-          </a:prstGeom>
-          <a:noFill/>
-        </p:spPr>
-        <p:txBody>
-          <a:bodyPr wrap="none">
-            <a:spAutoFit/>
-          </a:bodyPr>
-          <a:lstStyle/>
-          <a:p>
-            <a:r>
-              <a:rPr b="1" sz="1800">
-                <a:solidFill>
-                  <a:srgbClr val="34D399"/>
-                </a:solidFill>
-              </a:rPr>
-              <a:t>✓  Less waste — </a:t>
-            </a:r>
-            <a:r>
-              <a:rPr sz="1800">
-                <a:solidFill>
-                  <a:srgbClr val="FFFFFF"/>
-                </a:solidFill>
-              </a:rPr>
-              <a:t>Out-of-stock handling + remote order blocking</a:t>
-            </a:r>
-          </a:p>
-        </p:txBody>
-      </p:sp>
-      <p:sp>
-        <p:nvSpPr>
-          <p:cNvPr id="6" name="TextBox 5"/>
-          <p:cNvSpPr txBox="1"/>
-          <p:nvPr/>
-        </p:nvSpPr>
-        <p:spPr>
-          <a:xfrm>
-            <a:off x="731520" y="3429000"/>
-            <a:ext cx="10515600" cy="640080"/>
-          </a:xfrm>
-          <a:prstGeom prst="rect">
-            <a:avLst/>
-          </a:prstGeom>
-          <a:noFill/>
-        </p:spPr>
-        <p:txBody>
-          <a:bodyPr wrap="none">
-            <a:spAutoFit/>
-          </a:bodyPr>
-          <a:lstStyle/>
-          <a:p>
-            <a:r>
-              <a:rPr b="1" sz="1800">
-                <a:solidFill>
-                  <a:srgbClr val="34D399"/>
-                </a:solidFill>
-              </a:rPr>
-              <a:t>✓  Higher turnover — </a:t>
-            </a:r>
-            <a:r>
-              <a:rPr sz="1800">
-                <a:solidFill>
-                  <a:srgbClr val="FFFFFF"/>
-                </a:solidFill>
-              </a:rPr>
-              <a:t>Quicker payments, faster table reset</a:t>
-            </a:r>
-          </a:p>
-        </p:txBody>
-      </p:sp>
-      <p:sp>
-        <p:nvSpPr>
-          <p:cNvPr id="7" name="TextBox 6"/>
-          <p:cNvSpPr txBox="1"/>
-          <p:nvPr/>
-        </p:nvSpPr>
-        <p:spPr>
-          <a:xfrm>
-            <a:off x="731520" y="4114800"/>
-            <a:ext cx="10515600" cy="640080"/>
-          </a:xfrm>
-          <a:prstGeom prst="rect">
-            <a:avLst/>
-          </a:prstGeom>
-          <a:noFill/>
-        </p:spPr>
-        <p:txBody>
-          <a:bodyPr wrap="none">
-            <a:spAutoFit/>
-          </a:bodyPr>
-          <a:lstStyle/>
-          <a:p>
-            <a:r>
-              <a:rPr b="1" sz="1800">
-                <a:solidFill>
-                  <a:srgbClr val="34D399"/>
-                </a:solidFill>
-              </a:rPr>
-              <a:t>✓  Happier guests — </a:t>
-            </a:r>
-            <a:r>
-              <a:rPr sz="1800">
-                <a:solidFill>
-                  <a:srgbClr val="FFFFFF"/>
-                </a:solidFill>
-              </a:rPr>
-              <a:t>Transparency, games &amp; rewards while waiting</a:t>
-            </a:r>
-          </a:p>
-        </p:txBody>
-      </p:sp>
-      <p:sp>
-        <p:nvSpPr>
-          <p:cNvPr id="8" name="TextBox 7"/>
-          <p:cNvSpPr txBox="1"/>
-          <p:nvPr/>
-        </p:nvSpPr>
-        <p:spPr>
-          <a:xfrm>
-            <a:off x="731520" y="4800600"/>
-            <a:ext cx="10515600" cy="640080"/>
-          </a:xfrm>
-          <a:prstGeom prst="rect">
-            <a:avLst/>
-          </a:prstGeom>
-          <a:noFill/>
-        </p:spPr>
-        <p:txBody>
-          <a:bodyPr wrap="none">
-            <a:spAutoFit/>
-          </a:bodyPr>
-          <a:lstStyle/>
-          <a:p>
-            <a:r>
-              <a:rPr b="1" sz="1800">
-                <a:solidFill>
-                  <a:srgbClr val="34D399"/>
-                </a:solidFill>
-              </a:rPr>
-              <a:t>✓  Full control — </a:t>
-            </a:r>
-            <a:r>
-              <a:rPr sz="1800">
-                <a:solidFill>
-                  <a:srgbClr val="FFFFFF"/>
-                </a:solidFill>
-              </a:rPr>
-              <a:t>You own the menu, staff, QR codes &amp; reports</a:t>
-            </a:r>
-          </a:p>
-        </p:txBody>
-      </p:sp>
-      <p:sp>
-        <p:nvSpPr>
-          <p:cNvPr id="9" name="TextBox 8"/>
-          <p:cNvSpPr txBox="1"/>
-          <p:nvPr/>
-        </p:nvSpPr>
-        <p:spPr>
-          <a:xfrm>
-            <a:off x="548640" y="6400800"/>
-            <a:ext cx="10972800" cy="365760"/>
-          </a:xfrm>
-          <a:prstGeom prst="rect">
-            <a:avLst/>
-          </a:prstGeom>
-          <a:noFill/>
-        </p:spPr>
-        <p:txBody>
-          <a:bodyPr wrap="none">
-            <a:spAutoFit/>
-          </a:bodyPr>
-          <a:lstStyle/>
-          <a:p>
             <a:pPr>
               <a:defRPr sz="1100">
                 <a:solidFill>
@@ -4069,7 +4273,7 @@
               </a:defRPr>
             </a:pPr>
             <a:r>
-              <a:t>TableTap · Smart Restaurant Ordering</a:t>
+              <a:t>TableTap · Complete Restaurant Platform</a:t>
             </a:r>
           </a:p>
         </p:txBody>
@@ -4088,7 +4292,7 @@
     <p:bg>
       <p:bgPr>
         <a:solidFill>
-          <a:srgbClr val="0F0F1A"/>
+          <a:srgbClr val="08080E"/>
         </a:solidFill>
         <a:effectLst/>
       </p:bgPr>
@@ -4102,7 +4306,50 @@
       <p:grpSpPr/>
       <p:sp>
         <p:nvSpPr>
-          <p:cNvPr id="2" name="TextBox 1"/>
+          <p:cNvPr id="2" name="Rectangle 1"/>
+          <p:cNvSpPr/>
+          <p:nvPr/>
+        </p:nvSpPr>
+        <p:spPr>
+          <a:xfrm>
+            <a:off x="0" y="0"/>
+            <a:ext cx="12191695" cy="73152"/>
+          </a:xfrm>
+          <a:prstGeom prst="rect">
+            <a:avLst/>
+          </a:prstGeom>
+          <a:solidFill>
+            <a:srgbClr val="F97316"/>
+          </a:solidFill>
+          <a:ln>
+            <a:noFill/>
+          </a:ln>
+        </p:spPr>
+        <p:style>
+          <a:lnRef idx="1">
+            <a:schemeClr val="accent1"/>
+          </a:lnRef>
+          <a:fillRef idx="3">
+            <a:schemeClr val="accent1"/>
+          </a:fillRef>
+          <a:effectRef idx="2">
+            <a:schemeClr val="accent1"/>
+          </a:effectRef>
+          <a:fontRef idx="minor">
+            <a:schemeClr val="lt1"/>
+          </a:fontRef>
+        </p:style>
+        <p:txBody>
+          <a:bodyPr rtlCol="0" anchor="ctr"/>
+          <a:lstStyle/>
+          <a:p>
+            <a:pPr algn="ctr"/>
+          </a:p>
+        </p:txBody>
+      </p:sp>
+      <p:sp>
+        <p:nvSpPr>
+          <p:cNvPr id="3" name="TextBox 2"/>
           <p:cNvSpPr txBox="1"/>
           <p:nvPr/>
         </p:nvSpPr>
@@ -4130,7 +4377,7 @@
               </a:defRPr>
             </a:pPr>
             <a:r>
-              <a:t>Getting started</a:t>
+              <a:t>Role-based permissions</a:t>
             </a:r>
           </a:p>
           <a:p>
@@ -4145,14 +4392,14 @@
               </a:defRPr>
             </a:pPr>
             <a:r>
-              <a:t>Live in three steps</a:t>
-            </a:r>
-          </a:p>
-        </p:txBody>
-      </p:sp>
-      <p:sp>
-        <p:nvSpPr>
-          <p:cNvPr id="3" name="TextBox 2"/>
+              <a:t>Owner · Manager · Cook · Server · Platform admin</a:t>
+            </a:r>
+          </a:p>
+        </p:txBody>
+      </p:sp>
+      <p:sp>
+        <p:nvSpPr>
+          <p:cNvPr id="4" name="TextBox 3"/>
           <p:cNvSpPr txBox="1"/>
           <p:nvPr/>
         </p:nvSpPr>
@@ -4174,95 +4421,68 @@
           <a:p>
             <a:pPr>
               <a:spcAft>
-                <a:spcPts val="1000"/>
+                <a:spcPts val="800"/>
               </a:spcAft>
-              <a:defRPr sz="1800">
-                <a:solidFill>
-                  <a:srgbClr val="FFFFFF"/>
-                </a:solidFill>
-              </a:defRPr>
-            </a:pPr>
-            <a:r>
-              <a:t>1. Set up your menu, staff accounts &amp; table QR codes</a:t>
+              <a:defRPr sz="1700">
+                <a:solidFill>
+                  <a:srgbClr val="FFFFFF"/>
+                </a:solidFill>
+              </a:defRPr>
+            </a:pPr>
+            <a:r>
+              <a:t>Owner / Manager — dashboard, menu, QR, reports, integrations</a:t>
             </a:r>
           </a:p>
           <a:p>
             <a:pPr>
               <a:spcAft>
-                <a:spcPts val="1000"/>
+                <a:spcPts val="800"/>
               </a:spcAft>
-              <a:defRPr sz="1800">
-                <a:solidFill>
-                  <a:srgbClr val="FFFFFF"/>
-                </a:solidFill>
-              </a:defRPr>
-            </a:pPr>
-            <a:r>
-              <a:t>2. Print QR codes and place on each table</a:t>
+              <a:defRPr sz="1700">
+                <a:solidFill>
+                  <a:srgbClr val="FFFFFF"/>
+                </a:solidFill>
+              </a:defRPr>
+            </a:pPr>
+            <a:r>
+              <a:t>Cook — KDS, prepare items, mark unavailable</a:t>
             </a:r>
           </a:p>
           <a:p>
             <a:pPr>
               <a:spcAft>
-                <a:spcPts val="1000"/>
+                <a:spcPts val="800"/>
               </a:spcAft>
-              <a:defRPr sz="1800">
-                <a:solidFill>
-                  <a:srgbClr val="FFFFFF"/>
-                </a:solidFill>
-              </a:defRPr>
-            </a:pPr>
-            <a:r>
-              <a:t>3. Train staff: open table → guests scan → kitchen serves → mark paid</a:t>
+              <a:defRPr sz="1700">
+                <a:solidFill>
+                  <a:srgbClr val="FFFFFF"/>
+                </a:solidFill>
+              </a:defRPr>
+            </a:pPr>
+            <a:r>
+              <a:t>Server — floor plan, serve, open/close tables, payments</a:t>
             </a:r>
           </a:p>
           <a:p>
             <a:pPr>
               <a:spcAft>
-                <a:spcPts val="1000"/>
+                <a:spcPts val="800"/>
               </a:spcAft>
-              <a:defRPr sz="1800">
-                <a:solidFill>
-                  <a:srgbClr val="FFFFFF"/>
-                </a:solidFill>
-              </a:defRPr>
-            </a:pPr>
-          </a:p>
-          <a:p>
-            <a:pPr>
-              <a:spcAft>
-                <a:spcPts val="1000"/>
-              </a:spcAft>
-              <a:defRPr sz="1800">
-                <a:solidFill>
-                  <a:srgbClr val="FFFFFF"/>
-                </a:solidFill>
-              </a:defRPr>
-            </a:pPr>
-            <a:r>
-              <a:t>Demo login: owner@varanasi.com</a:t>
-            </a:r>
-          </a:p>
-          <a:p>
-            <a:pPr>
-              <a:spcAft>
-                <a:spcPts val="1000"/>
-              </a:spcAft>
-              <a:defRPr sz="1800">
-                <a:solidFill>
-                  <a:srgbClr val="FFFFFF"/>
-                </a:solidFill>
-              </a:defRPr>
-            </a:pPr>
-            <a:r>
-              <a:t>Customer demo: scan Table 1 QR or visit /order/varanasi/demo</a:t>
-            </a:r>
-          </a:p>
-        </p:txBody>
-      </p:sp>
-      <p:sp>
-        <p:nvSpPr>
-          <p:cNvPr id="4" name="TextBox 3"/>
+              <a:defRPr sz="1700">
+                <a:solidFill>
+                  <a:srgbClr val="FFFFFF"/>
+                </a:solidFill>
+              </a:defRPr>
+            </a:pPr>
+            <a:r>
+              <a:t>Platform admin — staff slots, premium toggles, credential export</a:t>
+            </a:r>
+          </a:p>
+        </p:txBody>
+      </p:sp>
+      <p:sp>
+        <p:nvSpPr>
+          <p:cNvPr id="5" name="TextBox 4"/>
           <p:cNvSpPr txBox="1"/>
           <p:nvPr/>
         </p:nvSpPr>
@@ -4290,7 +4510,7 @@
               </a:defRPr>
             </a:pPr>
             <a:r>
-              <a:t>Questions? Let's run a live demo at your restaurant.</a:t>
+              <a:t>TableTap · Complete Restaurant Platform</a:t>
             </a:r>
           </a:p>
         </p:txBody>
@@ -4309,7 +4529,7 @@
     <p:bg>
       <p:bgPr>
         <a:solidFill>
-          <a:srgbClr val="0F0F1A"/>
+          <a:srgbClr val="08080E"/>
         </a:solidFill>
         <a:effectLst/>
       </p:bgPr>
@@ -4329,8 +4549,8 @@
         </p:nvSpPr>
         <p:spPr>
           <a:xfrm>
-            <a:off x="0" y="6748272"/>
-            <a:ext cx="12191695" cy="109728"/>
+            <a:off x="0" y="0"/>
+            <a:ext cx="12191695" cy="73152"/>
           </a:xfrm>
           <a:prstGeom prst="rect">
             <a:avLst/>
@@ -4372,8 +4592,186 @@
         </p:nvSpPr>
         <p:spPr>
           <a:xfrm>
-            <a:off x="731520" y="2377440"/>
-            <a:ext cx="10515600" cy="1828800"/>
+            <a:off x="548640" y="411480"/>
+            <a:ext cx="11064240" cy="1097280"/>
+          </a:xfrm>
+          <a:prstGeom prst="rect">
+            <a:avLst/>
+          </a:prstGeom>
+          <a:noFill/>
+        </p:spPr>
+        <p:txBody>
+          <a:bodyPr wrap="square">
+            <a:spAutoFit/>
+          </a:bodyPr>
+          <a:lstStyle/>
+          <a:p>
+            <a:pPr>
+              <a:defRPr sz="3400" b="1">
+                <a:solidFill>
+                  <a:srgbClr val="FFFFFF"/>
+                </a:solidFill>
+              </a:defRPr>
+            </a:pPr>
+            <a:r>
+              <a:t>Technical setup</a:t>
+            </a:r>
+          </a:p>
+          <a:p>
+            <a:pPr>
+              <a:spcBef>
+                <a:spcPts val="800"/>
+              </a:spcBef>
+              <a:defRPr sz="1600">
+                <a:solidFill>
+                  <a:srgbClr val="A1A1AA"/>
+                </a:solidFill>
+              </a:defRPr>
+            </a:pPr>
+            <a:r>
+              <a:t>See SETUP_GUIDE.md for complete instructions</a:t>
+            </a:r>
+          </a:p>
+        </p:txBody>
+      </p:sp>
+      <p:sp>
+        <p:nvSpPr>
+          <p:cNvPr id="4" name="TextBox 3"/>
+          <p:cNvSpPr txBox="1"/>
+          <p:nvPr/>
+        </p:nvSpPr>
+        <p:spPr>
+          <a:xfrm>
+            <a:off x="640080" y="1463040"/>
+            <a:ext cx="10058400" cy="4572000"/>
+          </a:xfrm>
+          <a:prstGeom prst="rect">
+            <a:avLst/>
+          </a:prstGeom>
+          <a:noFill/>
+        </p:spPr>
+        <p:txBody>
+          <a:bodyPr wrap="square">
+            <a:spAutoFit/>
+          </a:bodyPr>
+          <a:lstStyle/>
+          <a:p>
+            <a:pPr>
+              <a:spcAft>
+                <a:spcPts val="800"/>
+              </a:spcAft>
+              <a:defRPr sz="1700">
+                <a:solidFill>
+                  <a:srgbClr val="FFFFFF"/>
+                </a:solidFill>
+              </a:defRPr>
+            </a:pPr>
+            <a:r>
+              <a:t>1. npm install &amp;&amp; npm run setup -- --start</a:t>
+            </a:r>
+          </a:p>
+          <a:p>
+            <a:pPr>
+              <a:spcAft>
+                <a:spcPts val="800"/>
+              </a:spcAft>
+              <a:defRPr sz="1700">
+                <a:solidFill>
+                  <a:srgbClr val="FFFFFF"/>
+                </a:solidFill>
+              </a:defRPr>
+            </a:pPr>
+            <a:r>
+              <a:t>2. Edit restaurant.config.json (name, staff, menu, tables)</a:t>
+            </a:r>
+          </a:p>
+          <a:p>
+            <a:pPr>
+              <a:spcAft>
+                <a:spcPts val="800"/>
+              </a:spcAft>
+              <a:defRPr sz="1700">
+                <a:solidFill>
+                  <a:srgbClr val="FFFFFF"/>
+                </a:solidFill>
+              </a:defRPr>
+            </a:pPr>
+            <a:r>
+              <a:t>3. Set NEXT_PUBLIC_APP_URL to your LAN IP or domain</a:t>
+            </a:r>
+          </a:p>
+          <a:p>
+            <a:pPr>
+              <a:spcAft>
+                <a:spcPts val="800"/>
+              </a:spcAft>
+              <a:defRPr sz="1700">
+                <a:solidFill>
+                  <a:srgbClr val="FFFFFF"/>
+                </a:solidFill>
+              </a:defRPr>
+            </a:pPr>
+            <a:r>
+              <a:t>4. Print QR codes from admin</a:t>
+            </a:r>
+          </a:p>
+          <a:p>
+            <a:pPr>
+              <a:spcAft>
+                <a:spcPts val="800"/>
+              </a:spcAft>
+              <a:defRPr sz="1700">
+                <a:solidFill>
+                  <a:srgbClr val="FFFFFF"/>
+                </a:solidFill>
+              </a:defRPr>
+            </a:pPr>
+            <a:r>
+              <a:t>5. Enable premium modules from /platform/login</a:t>
+            </a:r>
+          </a:p>
+          <a:p>
+            <a:pPr>
+              <a:spcAft>
+                <a:spcPts val="800"/>
+              </a:spcAft>
+              <a:defRPr sz="1700">
+                <a:solidFill>
+                  <a:srgbClr val="FFFFFF"/>
+                </a:solidFill>
+              </a:defRPr>
+            </a:pPr>
+            <a:r>
+              <a:t>6. Docker: docker compose up --build (PostgreSQL production)</a:t>
+            </a:r>
+          </a:p>
+          <a:p>
+            <a:pPr>
+              <a:spcAft>
+                <a:spcPts val="800"/>
+              </a:spcAft>
+              <a:defRPr sz="1700">
+                <a:solidFill>
+                  <a:srgbClr val="FFFFFF"/>
+                </a:solidFill>
+              </a:defRPr>
+            </a:pPr>
+            <a:r>
+              <a:t>7. Swiggy/Zomato: Admin → Integrations + partner webhook registration</a:t>
+            </a:r>
+          </a:p>
+        </p:txBody>
+      </p:sp>
+      <p:sp>
+        <p:nvSpPr>
+          <p:cNvPr id="5" name="TextBox 4"/>
+          <p:cNvSpPr txBox="1"/>
+          <p:nvPr/>
+        </p:nvSpPr>
+        <p:spPr>
+          <a:xfrm>
+            <a:off x="548640" y="6400800"/>
+            <a:ext cx="10972800" cy="365760"/>
           </a:xfrm>
           <a:prstGeom prst="rect">
             <a:avLst/>
@@ -4386,8 +4784,849 @@
           </a:bodyPr>
           <a:lstStyle/>
           <a:p>
+            <a:pPr>
+              <a:defRPr sz="1100">
+                <a:solidFill>
+                  <a:srgbClr val="A1A1AA"/>
+                </a:solidFill>
+              </a:defRPr>
+            </a:pPr>
+            <a:r>
+              <a:t>TableTap · Complete Restaurant Platform</a:t>
+            </a:r>
+          </a:p>
+        </p:txBody>
+      </p:sp>
+    </p:spTree>
+  </p:cSld>
+  <p:clrMapOvr>
+    <a:masterClrMapping/>
+  </p:clrMapOvr>
+</p:sld>
+</file>
+
+<file path=ppt/slides/slide16.xml><?xml version="1.0" encoding="utf-8"?>
+<p:sld xmlns:a="http://schemas.openxmlformats.org/drawingml/2006/main" xmlns:p="http://schemas.openxmlformats.org/presentationml/2006/main" xmlns:r="http://schemas.openxmlformats.org/officeDocument/2006/relationships">
+  <p:cSld>
+    <p:bg>
+      <p:bgPr>
+        <a:solidFill>
+          <a:srgbClr val="08080E"/>
+        </a:solidFill>
+        <a:effectLst/>
+      </p:bgPr>
+    </p:bg>
+    <p:spTree>
+      <p:nvGrpSpPr>
+        <p:cNvPr id="1" name=""/>
+        <p:cNvGrpSpPr/>
+        <p:nvPr/>
+      </p:nvGrpSpPr>
+      <p:grpSpPr/>
+      <p:sp>
+        <p:nvSpPr>
+          <p:cNvPr id="2" name="Rectangle 1"/>
+          <p:cNvSpPr/>
+          <p:nvPr/>
+        </p:nvSpPr>
+        <p:spPr>
+          <a:xfrm>
+            <a:off x="0" y="0"/>
+            <a:ext cx="12191695" cy="73152"/>
+          </a:xfrm>
+          <a:prstGeom prst="rect">
+            <a:avLst/>
+          </a:prstGeom>
+          <a:solidFill>
+            <a:srgbClr val="F97316"/>
+          </a:solidFill>
+          <a:ln>
+            <a:noFill/>
+          </a:ln>
+        </p:spPr>
+        <p:style>
+          <a:lnRef idx="1">
+            <a:schemeClr val="accent1"/>
+          </a:lnRef>
+          <a:fillRef idx="3">
+            <a:schemeClr val="accent1"/>
+          </a:fillRef>
+          <a:effectRef idx="2">
+            <a:schemeClr val="accent1"/>
+          </a:effectRef>
+          <a:fontRef idx="minor">
+            <a:schemeClr val="lt1"/>
+          </a:fontRef>
+        </p:style>
+        <p:txBody>
+          <a:bodyPr rtlCol="0" anchor="ctr"/>
+          <a:lstStyle/>
+          <a:p>
+            <a:pPr algn="ctr"/>
+          </a:p>
+        </p:txBody>
+      </p:sp>
+      <p:sp>
+        <p:nvSpPr>
+          <p:cNvPr id="3" name="TextBox 2"/>
+          <p:cNvSpPr txBox="1"/>
+          <p:nvPr/>
+        </p:nvSpPr>
+        <p:spPr>
+          <a:xfrm>
+            <a:off x="548640" y="411480"/>
+            <a:ext cx="11064240" cy="1097280"/>
+          </a:xfrm>
+          <a:prstGeom prst="rect">
+            <a:avLst/>
+          </a:prstGeom>
+          <a:noFill/>
+        </p:spPr>
+        <p:txBody>
+          <a:bodyPr wrap="square">
+            <a:spAutoFit/>
+          </a:bodyPr>
+          <a:lstStyle/>
+          <a:p>
+            <a:pPr>
+              <a:defRPr sz="3400" b="1">
+                <a:solidFill>
+                  <a:srgbClr val="FFFFFF"/>
+                </a:solidFill>
+              </a:defRPr>
+            </a:pPr>
+            <a:r>
+              <a:t>Benefits for restaurant owners</a:t>
+            </a:r>
+          </a:p>
+          <a:p>
+            <a:pPr>
+              <a:spcBef>
+                <a:spcPts val="800"/>
+              </a:spcBef>
+              <a:defRPr sz="1600">
+                <a:solidFill>
+                  <a:srgbClr val="A1A1AA"/>
+                </a:solidFill>
+              </a:defRPr>
+            </a:pPr>
+            <a:r>
+              <a:t>Why TableTap pays for itself</a:t>
+            </a:r>
+          </a:p>
+        </p:txBody>
+      </p:sp>
+      <p:sp>
+        <p:nvSpPr>
+          <p:cNvPr id="4" name="TextBox 3"/>
+          <p:cNvSpPr txBox="1"/>
+          <p:nvPr/>
+        </p:nvSpPr>
+        <p:spPr>
+          <a:xfrm>
+            <a:off x="731520" y="1371600"/>
+            <a:ext cx="10515600" cy="640080"/>
+          </a:xfrm>
+          <a:prstGeom prst="rect">
+            <a:avLst/>
+          </a:prstGeom>
+          <a:noFill/>
+        </p:spPr>
+        <p:txBody>
+          <a:bodyPr wrap="none">
+            <a:spAutoFit/>
+          </a:bodyPr>
+          <a:lstStyle/>
+          <a:p>
+            <a:r>
+              <a:rPr b="1" sz="1800">
+                <a:solidFill>
+                  <a:srgbClr val="34D399"/>
+                </a:solidFill>
+              </a:rPr>
+              <a:t>✓  Faster service — </a:t>
+            </a:r>
+            <a:r>
+              <a:rPr sz="1800">
+                <a:solidFill>
+                  <a:srgbClr val="FFFFFF"/>
+                </a:solidFill>
+              </a:rPr>
+              <a:t>Guests order without waiting for staff</a:t>
+            </a:r>
+          </a:p>
+        </p:txBody>
+      </p:sp>
+      <p:sp>
+        <p:nvSpPr>
+          <p:cNvPr id="5" name="TextBox 4"/>
+          <p:cNvSpPr txBox="1"/>
+          <p:nvPr/>
+        </p:nvSpPr>
+        <p:spPr>
+          <a:xfrm>
+            <a:off x="731520" y="2057400"/>
+            <a:ext cx="10515600" cy="640080"/>
+          </a:xfrm>
+          <a:prstGeom prst="rect">
+            <a:avLst/>
+          </a:prstGeom>
+          <a:noFill/>
+        </p:spPr>
+        <p:txBody>
+          <a:bodyPr wrap="none">
+            <a:spAutoFit/>
+          </a:bodyPr>
+          <a:lstStyle/>
+          <a:p>
+            <a:r>
+              <a:rPr b="1" sz="1800">
+                <a:solidFill>
+                  <a:srgbClr val="34D399"/>
+                </a:solidFill>
+              </a:rPr>
+              <a:t>✓  One system — </a:t>
+            </a:r>
+            <a:r>
+              <a:rPr sz="1800">
+                <a:solidFill>
+                  <a:srgbClr val="FFFFFF"/>
+                </a:solidFill>
+              </a:rPr>
+              <a:t>Dine-in + takeaway + Swiggy + Zomato</a:t>
+            </a:r>
+          </a:p>
+        </p:txBody>
+      </p:sp>
+      <p:sp>
+        <p:nvSpPr>
+          <p:cNvPr id="6" name="TextBox 5"/>
+          <p:cNvSpPr txBox="1"/>
+          <p:nvPr/>
+        </p:nvSpPr>
+        <p:spPr>
+          <a:xfrm>
+            <a:off x="731520" y="2743200"/>
+            <a:ext cx="10515600" cy="640080"/>
+          </a:xfrm>
+          <a:prstGeom prst="rect">
+            <a:avLst/>
+          </a:prstGeom>
+          <a:noFill/>
+        </p:spPr>
+        <p:txBody>
+          <a:bodyPr wrap="none">
+            <a:spAutoFit/>
+          </a:bodyPr>
+          <a:lstStyle/>
+          <a:p>
+            <a:r>
+              <a:rPr b="1" sz="1800">
+                <a:solidFill>
+                  <a:srgbClr val="34D399"/>
+                </a:solidFill>
+              </a:rPr>
+              <a:t>✓  Less waste — </a:t>
+            </a:r>
+            <a:r>
+              <a:rPr sz="1800">
+                <a:solidFill>
+                  <a:srgbClr val="FFFFFF"/>
+                </a:solidFill>
+              </a:rPr>
+              <a:t>Stock control + remote order blocking</a:t>
+            </a:r>
+          </a:p>
+        </p:txBody>
+      </p:sp>
+      <p:sp>
+        <p:nvSpPr>
+          <p:cNvPr id="7" name="TextBox 6"/>
+          <p:cNvSpPr txBox="1"/>
+          <p:nvPr/>
+        </p:nvSpPr>
+        <p:spPr>
+          <a:xfrm>
+            <a:off x="731520" y="3429000"/>
+            <a:ext cx="10515600" cy="640080"/>
+          </a:xfrm>
+          <a:prstGeom prst="rect">
+            <a:avLst/>
+          </a:prstGeom>
+          <a:noFill/>
+        </p:spPr>
+        <p:txBody>
+          <a:bodyPr wrap="none">
+            <a:spAutoFit/>
+          </a:bodyPr>
+          <a:lstStyle/>
+          <a:p>
+            <a:r>
+              <a:rPr b="1" sz="1800">
+                <a:solidFill>
+                  <a:srgbClr val="34D399"/>
+                </a:solidFill>
+              </a:rPr>
+              <a:t>✓  Higher turnover — </a:t>
+            </a:r>
+            <a:r>
+              <a:rPr sz="1800">
+                <a:solidFill>
+                  <a:srgbClr val="FFFFFF"/>
+                </a:solidFill>
+              </a:rPr>
+              <a:t>Quicker payments, faster table reset</a:t>
+            </a:r>
+          </a:p>
+        </p:txBody>
+      </p:sp>
+      <p:sp>
+        <p:nvSpPr>
+          <p:cNvPr id="8" name="TextBox 7"/>
+          <p:cNvSpPr txBox="1"/>
+          <p:nvPr/>
+        </p:nvSpPr>
+        <p:spPr>
+          <a:xfrm>
+            <a:off x="731520" y="4114800"/>
+            <a:ext cx="10515600" cy="640080"/>
+          </a:xfrm>
+          <a:prstGeom prst="rect">
+            <a:avLst/>
+          </a:prstGeom>
+          <a:noFill/>
+        </p:spPr>
+        <p:txBody>
+          <a:bodyPr wrap="none">
+            <a:spAutoFit/>
+          </a:bodyPr>
+          <a:lstStyle/>
+          <a:p>
+            <a:r>
+              <a:rPr b="1" sz="1800">
+                <a:solidFill>
+                  <a:srgbClr val="34D399"/>
+                </a:solidFill>
+              </a:rPr>
+              <a:t>✓  Kitchen clarity — </a:t>
+            </a:r>
+            <a:r>
+              <a:rPr sz="1800">
+                <a:solidFill>
+                  <a:srgbClr val="FFFFFF"/>
+                </a:solidFill>
+              </a:rPr>
+              <a:t>KDS + timers replace paper chaos</a:t>
+            </a:r>
+          </a:p>
+        </p:txBody>
+      </p:sp>
+      <p:sp>
+        <p:nvSpPr>
+          <p:cNvPr id="9" name="TextBox 8"/>
+          <p:cNvSpPr txBox="1"/>
+          <p:nvPr/>
+        </p:nvSpPr>
+        <p:spPr>
+          <a:xfrm>
+            <a:off x="731520" y="4800600"/>
+            <a:ext cx="10515600" cy="640080"/>
+          </a:xfrm>
+          <a:prstGeom prst="rect">
+            <a:avLst/>
+          </a:prstGeom>
+          <a:noFill/>
+        </p:spPr>
+        <p:txBody>
+          <a:bodyPr wrap="none">
+            <a:spAutoFit/>
+          </a:bodyPr>
+          <a:lstStyle/>
+          <a:p>
+            <a:r>
+              <a:rPr b="1" sz="1800">
+                <a:solidFill>
+                  <a:srgbClr val="34D399"/>
+                </a:solidFill>
+              </a:rPr>
+              <a:t>✓  Full control — </a:t>
+            </a:r>
+            <a:r>
+              <a:rPr sz="1800">
+                <a:solidFill>
+                  <a:srgbClr val="FFFFFF"/>
+                </a:solidFill>
+              </a:rPr>
+              <a:t>You own menu, staff, QR, reports, integrations</a:t>
+            </a:r>
+          </a:p>
+        </p:txBody>
+      </p:sp>
+      <p:sp>
+        <p:nvSpPr>
+          <p:cNvPr id="10" name="TextBox 9"/>
+          <p:cNvSpPr txBox="1"/>
+          <p:nvPr/>
+        </p:nvSpPr>
+        <p:spPr>
+          <a:xfrm>
+            <a:off x="548640" y="6400800"/>
+            <a:ext cx="10972800" cy="365760"/>
+          </a:xfrm>
+          <a:prstGeom prst="rect">
+            <a:avLst/>
+          </a:prstGeom>
+          <a:noFill/>
+        </p:spPr>
+        <p:txBody>
+          <a:bodyPr wrap="none">
+            <a:spAutoFit/>
+          </a:bodyPr>
+          <a:lstStyle/>
+          <a:p>
+            <a:pPr>
+              <a:defRPr sz="1100">
+                <a:solidFill>
+                  <a:srgbClr val="A1A1AA"/>
+                </a:solidFill>
+              </a:defRPr>
+            </a:pPr>
+            <a:r>
+              <a:t>TableTap · Complete Restaurant Platform</a:t>
+            </a:r>
+          </a:p>
+        </p:txBody>
+      </p:sp>
+    </p:spTree>
+  </p:cSld>
+  <p:clrMapOvr>
+    <a:masterClrMapping/>
+  </p:clrMapOvr>
+</p:sld>
+</file>
+
+<file path=ppt/slides/slide17.xml><?xml version="1.0" encoding="utf-8"?>
+<p:sld xmlns:a="http://schemas.openxmlformats.org/drawingml/2006/main" xmlns:p="http://schemas.openxmlformats.org/presentationml/2006/main" xmlns:r="http://schemas.openxmlformats.org/officeDocument/2006/relationships">
+  <p:cSld>
+    <p:bg>
+      <p:bgPr>
+        <a:solidFill>
+          <a:srgbClr val="08080E"/>
+        </a:solidFill>
+        <a:effectLst/>
+      </p:bgPr>
+    </p:bg>
+    <p:spTree>
+      <p:nvGrpSpPr>
+        <p:cNvPr id="1" name=""/>
+        <p:cNvGrpSpPr/>
+        <p:nvPr/>
+      </p:nvGrpSpPr>
+      <p:grpSpPr/>
+      <p:sp>
+        <p:nvSpPr>
+          <p:cNvPr id="2" name="Rectangle 1"/>
+          <p:cNvSpPr/>
+          <p:nvPr/>
+        </p:nvSpPr>
+        <p:spPr>
+          <a:xfrm>
+            <a:off x="0" y="0"/>
+            <a:ext cx="12191695" cy="73152"/>
+          </a:xfrm>
+          <a:prstGeom prst="rect">
+            <a:avLst/>
+          </a:prstGeom>
+          <a:solidFill>
+            <a:srgbClr val="F97316"/>
+          </a:solidFill>
+          <a:ln>
+            <a:noFill/>
+          </a:ln>
+        </p:spPr>
+        <p:style>
+          <a:lnRef idx="1">
+            <a:schemeClr val="accent1"/>
+          </a:lnRef>
+          <a:fillRef idx="3">
+            <a:schemeClr val="accent1"/>
+          </a:fillRef>
+          <a:effectRef idx="2">
+            <a:schemeClr val="accent1"/>
+          </a:effectRef>
+          <a:fontRef idx="minor">
+            <a:schemeClr val="lt1"/>
+          </a:fontRef>
+        </p:style>
+        <p:txBody>
+          <a:bodyPr rtlCol="0" anchor="ctr"/>
+          <a:lstStyle/>
+          <a:p>
+            <a:pPr algn="ctr"/>
+          </a:p>
+        </p:txBody>
+      </p:sp>
+      <p:sp>
+        <p:nvSpPr>
+          <p:cNvPr id="3" name="TextBox 2"/>
+          <p:cNvSpPr txBox="1"/>
+          <p:nvPr/>
+        </p:nvSpPr>
+        <p:spPr>
+          <a:xfrm>
+            <a:off x="548640" y="411480"/>
+            <a:ext cx="11064240" cy="1097280"/>
+          </a:xfrm>
+          <a:prstGeom prst="rect">
+            <a:avLst/>
+          </a:prstGeom>
+          <a:noFill/>
+        </p:spPr>
+        <p:txBody>
+          <a:bodyPr wrap="square">
+            <a:spAutoFit/>
+          </a:bodyPr>
+          <a:lstStyle/>
+          <a:p>
+            <a:pPr>
+              <a:defRPr sz="3400" b="1">
+                <a:solidFill>
+                  <a:srgbClr val="FFFFFF"/>
+                </a:solidFill>
+              </a:defRPr>
+            </a:pPr>
+            <a:r>
+              <a:t>Live demo credentials</a:t>
+            </a:r>
+          </a:p>
+          <a:p>
+            <a:pPr>
+              <a:spcBef>
+                <a:spcPts val="800"/>
+              </a:spcBef>
+              <a:defRPr sz="1600">
+                <a:solidFill>
+                  <a:srgbClr val="A1A1AA"/>
+                </a:solidFill>
+              </a:defRPr>
+            </a:pPr>
+            <a:r>
+              <a:t>Varanasi Restaurant demo</a:t>
+            </a:r>
+          </a:p>
+        </p:txBody>
+      </p:sp>
+      <p:sp>
+        <p:nvSpPr>
+          <p:cNvPr id="4" name="TextBox 3"/>
+          <p:cNvSpPr txBox="1"/>
+          <p:nvPr/>
+        </p:nvSpPr>
+        <p:spPr>
+          <a:xfrm>
+            <a:off x="640080" y="1463040"/>
+            <a:ext cx="10058400" cy="4572000"/>
+          </a:xfrm>
+          <a:prstGeom prst="rect">
+            <a:avLst/>
+          </a:prstGeom>
+          <a:noFill/>
+        </p:spPr>
+        <p:txBody>
+          <a:bodyPr wrap="square">
+            <a:spAutoFit/>
+          </a:bodyPr>
+          <a:lstStyle/>
+          <a:p>
+            <a:pPr>
+              <a:spcAft>
+                <a:spcPts val="800"/>
+              </a:spcAft>
+              <a:defRPr sz="1700">
+                <a:solidFill>
+                  <a:srgbClr val="FFFFFF"/>
+                </a:solidFill>
+              </a:defRPr>
+            </a:pPr>
+            <a:r>
+              <a:t>Staff login: owner@varanasi.com / admin123</a:t>
+            </a:r>
+          </a:p>
+          <a:p>
+            <a:pPr>
+              <a:spcAft>
+                <a:spcPts val="800"/>
+              </a:spcAft>
+              <a:defRPr sz="1700">
+                <a:solidFill>
+                  <a:srgbClr val="FFFFFF"/>
+                </a:solidFill>
+              </a:defRPr>
+            </a:pPr>
+            <a:r>
+              <a:t>Super admin: admin@varanasi.com / admin@varanasi → /platform/login</a:t>
+            </a:r>
+          </a:p>
+          <a:p>
+            <a:pPr>
+              <a:spcAft>
+                <a:spcPts val="800"/>
+              </a:spcAft>
+              <a:defRPr sz="1700">
+                <a:solidFill>
+                  <a:srgbClr val="FFFFFF"/>
+                </a:solidFill>
+              </a:defRPr>
+            </a:pPr>
+            <a:r>
+              <a:t>Customer: scan Table 1 QR from staff dashboard</a:t>
+            </a:r>
+          </a:p>
+          <a:p>
+            <a:pPr>
+              <a:spcAft>
+                <a:spcPts val="800"/>
+              </a:spcAft>
+              <a:defRPr sz="1700">
+                <a:solidFill>
+                  <a:srgbClr val="FFFFFF"/>
+                </a:solidFill>
+              </a:defRPr>
+            </a:pPr>
+          </a:p>
+          <a:p>
+            <a:pPr>
+              <a:spcAft>
+                <a:spcPts val="800"/>
+              </a:spcAft>
+              <a:defRPr sz="1700">
+                <a:solidFill>
+                  <a:srgbClr val="FFFFFF"/>
+                </a:solidFill>
+              </a:defRPr>
+            </a:pPr>
+            <a:r>
+              <a:t>Documentation:</a:t>
+            </a:r>
+          </a:p>
+          <a:p>
+            <a:pPr>
+              <a:spcAft>
+                <a:spcPts val="800"/>
+              </a:spcAft>
+              <a:defRPr sz="1700">
+                <a:solidFill>
+                  <a:srgbClr val="FFFFFF"/>
+                </a:solidFill>
+              </a:defRPr>
+            </a:pPr>
+            <a:r>
+              <a:t>  SETUP_GUIDE.md — complete setup</a:t>
+            </a:r>
+          </a:p>
+          <a:p>
+            <a:pPr>
+              <a:spcAft>
+                <a:spcPts val="800"/>
+              </a:spcAft>
+              <a:defRPr sz="1700">
+                <a:solidFill>
+                  <a:srgbClr val="FFFFFF"/>
+                </a:solidFill>
+              </a:defRPr>
+            </a:pPr>
+            <a:r>
+              <a:t>  AGGREGATOR_SETUP.md — Swiggy/Zomato</a:t>
+            </a:r>
+          </a:p>
+          <a:p>
+            <a:pPr>
+              <a:spcAft>
+                <a:spcPts val="800"/>
+              </a:spcAft>
+              <a:defRPr sz="1700">
+                <a:solidFill>
+                  <a:srgbClr val="FFFFFF"/>
+                </a:solidFill>
+              </a:defRPr>
+            </a:pPr>
+            <a:r>
+              <a:t>  PREMIUM_FEATURES.md — module list</a:t>
+            </a:r>
+          </a:p>
+        </p:txBody>
+      </p:sp>
+      <p:sp>
+        <p:nvSpPr>
+          <p:cNvPr id="5" name="TextBox 4"/>
+          <p:cNvSpPr txBox="1"/>
+          <p:nvPr/>
+        </p:nvSpPr>
+        <p:spPr>
+          <a:xfrm>
+            <a:off x="548640" y="6400800"/>
+            <a:ext cx="10972800" cy="365760"/>
+          </a:xfrm>
+          <a:prstGeom prst="rect">
+            <a:avLst/>
+          </a:prstGeom>
+          <a:noFill/>
+        </p:spPr>
+        <p:txBody>
+          <a:bodyPr wrap="none">
+            <a:spAutoFit/>
+          </a:bodyPr>
+          <a:lstStyle/>
+          <a:p>
+            <a:pPr>
+              <a:defRPr sz="1100">
+                <a:solidFill>
+                  <a:srgbClr val="A1A1AA"/>
+                </a:solidFill>
+              </a:defRPr>
+            </a:pPr>
+            <a:r>
+              <a:t>Let's run a live demo at your restaurant.</a:t>
+            </a:r>
+          </a:p>
+        </p:txBody>
+      </p:sp>
+    </p:spTree>
+  </p:cSld>
+  <p:clrMapOvr>
+    <a:masterClrMapping/>
+  </p:clrMapOvr>
+</p:sld>
+</file>
+
+<file path=ppt/slides/slide18.xml><?xml version="1.0" encoding="utf-8"?>
+<p:sld xmlns:a="http://schemas.openxmlformats.org/drawingml/2006/main" xmlns:p="http://schemas.openxmlformats.org/presentationml/2006/main" xmlns:r="http://schemas.openxmlformats.org/officeDocument/2006/relationships">
+  <p:cSld>
+    <p:bg>
+      <p:bgPr>
+        <a:solidFill>
+          <a:srgbClr val="08080E"/>
+        </a:solidFill>
+        <a:effectLst/>
+      </p:bgPr>
+    </p:bg>
+    <p:spTree>
+      <p:nvGrpSpPr>
+        <p:cNvPr id="1" name=""/>
+        <p:cNvGrpSpPr/>
+        <p:nvPr/>
+      </p:nvGrpSpPr>
+      <p:grpSpPr/>
+      <p:sp>
+        <p:nvSpPr>
+          <p:cNvPr id="2" name="Rectangle 1"/>
+          <p:cNvSpPr/>
+          <p:nvPr/>
+        </p:nvSpPr>
+        <p:spPr>
+          <a:xfrm>
+            <a:off x="0" y="0"/>
+            <a:ext cx="12191695" cy="73152"/>
+          </a:xfrm>
+          <a:prstGeom prst="rect">
+            <a:avLst/>
+          </a:prstGeom>
+          <a:solidFill>
+            <a:srgbClr val="F97316"/>
+          </a:solidFill>
+          <a:ln>
+            <a:noFill/>
+          </a:ln>
+        </p:spPr>
+        <p:style>
+          <a:lnRef idx="1">
+            <a:schemeClr val="accent1"/>
+          </a:lnRef>
+          <a:fillRef idx="3">
+            <a:schemeClr val="accent1"/>
+          </a:fillRef>
+          <a:effectRef idx="2">
+            <a:schemeClr val="accent1"/>
+          </a:effectRef>
+          <a:fontRef idx="minor">
+            <a:schemeClr val="lt1"/>
+          </a:fontRef>
+        </p:style>
+        <p:txBody>
+          <a:bodyPr rtlCol="0" anchor="ctr"/>
+          <a:lstStyle/>
+          <a:p>
+            <a:pPr algn="ctr"/>
+          </a:p>
+        </p:txBody>
+      </p:sp>
+      <p:sp>
+        <p:nvSpPr>
+          <p:cNvPr id="3" name="Rectangle 2"/>
+          <p:cNvSpPr/>
+          <p:nvPr/>
+        </p:nvSpPr>
+        <p:spPr>
+          <a:xfrm>
+            <a:off x="0" y="6720840"/>
+            <a:ext cx="12191695" cy="109728"/>
+          </a:xfrm>
+          <a:prstGeom prst="rect">
+            <a:avLst/>
+          </a:prstGeom>
+          <a:solidFill>
+            <a:srgbClr val="F97316"/>
+          </a:solidFill>
+          <a:ln>
+            <a:noFill/>
+          </a:ln>
+        </p:spPr>
+        <p:style>
+          <a:lnRef idx="1">
+            <a:schemeClr val="accent1"/>
+          </a:lnRef>
+          <a:fillRef idx="3">
+            <a:schemeClr val="accent1"/>
+          </a:fillRef>
+          <a:effectRef idx="2">
+            <a:schemeClr val="accent1"/>
+          </a:effectRef>
+          <a:fontRef idx="minor">
+            <a:schemeClr val="lt1"/>
+          </a:fontRef>
+        </p:style>
+        <p:txBody>
+          <a:bodyPr rtlCol="0" anchor="ctr"/>
+          <a:lstStyle/>
+          <a:p>
+            <a:pPr algn="ctr"/>
+          </a:p>
+        </p:txBody>
+      </p:sp>
+      <p:sp>
+        <p:nvSpPr>
+          <p:cNvPr id="4" name="TextBox 3"/>
+          <p:cNvSpPr txBox="1"/>
+          <p:nvPr/>
+        </p:nvSpPr>
+        <p:spPr>
+          <a:xfrm>
+            <a:off x="731520" y="2194560"/>
+            <a:ext cx="10515600" cy="2286000"/>
+          </a:xfrm>
+          <a:prstGeom prst="rect">
+            <a:avLst/>
+          </a:prstGeom>
+          <a:noFill/>
+        </p:spPr>
+        <p:txBody>
+          <a:bodyPr wrap="none">
+            <a:spAutoFit/>
+          </a:bodyPr>
+          <a:lstStyle/>
+          <a:p>
             <a:pPr algn="ctr">
-              <a:defRPr sz="4800" b="1">
+              <a:defRPr sz="5200" b="1">
                 <a:solidFill>
                   <a:srgbClr val="FFFFFF"/>
                 </a:solidFill>
@@ -4402,14 +5641,29 @@
               <a:spcBef>
                 <a:spcPts val="1600"/>
               </a:spcBef>
-              <a:defRPr sz="2200">
+              <a:defRPr sz="2400">
                 <a:solidFill>
                   <a:srgbClr val="F97316"/>
                 </a:solidFill>
               </a:defRPr>
             </a:pPr>
             <a:r>
-              <a:t>TableTap — Scan · Order · Enjoy</a:t>
+              <a:t>TableTap — Scan · Order · Serve · Grow</a:t>
+            </a:r>
+          </a:p>
+          <a:p>
+            <a:pPr algn="ctr">
+              <a:spcBef>
+                <a:spcPts val="1200"/>
+              </a:spcBef>
+              <a:defRPr sz="1600">
+                <a:solidFill>
+                  <a:srgbClr val="A1A1AA"/>
+                </a:solidFill>
+              </a:defRPr>
+            </a:pPr>
+            <a:r>
+              <a:t>Complete setup guide included · Ready for your restaurant</a:t>
             </a:r>
           </a:p>
         </p:txBody>
@@ -4428,7 +5682,7 @@
     <p:bg>
       <p:bgPr>
         <a:solidFill>
-          <a:srgbClr val="0F0F1A"/>
+          <a:srgbClr val="08080E"/>
         </a:solidFill>
         <a:effectLst/>
       </p:bgPr>
@@ -4442,7 +5696,50 @@
       <p:grpSpPr/>
       <p:sp>
         <p:nvSpPr>
-          <p:cNvPr id="2" name="TextBox 1"/>
+          <p:cNvPr id="2" name="Rectangle 1"/>
+          <p:cNvSpPr/>
+          <p:nvPr/>
+        </p:nvSpPr>
+        <p:spPr>
+          <a:xfrm>
+            <a:off x="0" y="0"/>
+            <a:ext cx="12191695" cy="73152"/>
+          </a:xfrm>
+          <a:prstGeom prst="rect">
+            <a:avLst/>
+          </a:prstGeom>
+          <a:solidFill>
+            <a:srgbClr val="F97316"/>
+          </a:solidFill>
+          <a:ln>
+            <a:noFill/>
+          </a:ln>
+        </p:spPr>
+        <p:style>
+          <a:lnRef idx="1">
+            <a:schemeClr val="accent1"/>
+          </a:lnRef>
+          <a:fillRef idx="3">
+            <a:schemeClr val="accent1"/>
+          </a:fillRef>
+          <a:effectRef idx="2">
+            <a:schemeClr val="accent1"/>
+          </a:effectRef>
+          <a:fontRef idx="minor">
+            <a:schemeClr val="lt1"/>
+          </a:fontRef>
+        </p:style>
+        <p:txBody>
+          <a:bodyPr rtlCol="0" anchor="ctr"/>
+          <a:lstStyle/>
+          <a:p>
+            <a:pPr algn="ctr"/>
+          </a:p>
+        </p:txBody>
+      </p:sp>
+      <p:sp>
+        <p:nvSpPr>
+          <p:cNvPr id="3" name="TextBox 2"/>
           <p:cNvSpPr txBox="1"/>
           <p:nvPr/>
         </p:nvSpPr>
@@ -4470,7 +5767,7 @@
               </a:defRPr>
             </a:pPr>
             <a:r>
-              <a:t>The problem restaurants face</a:t>
+              <a:t>The problem</a:t>
             </a:r>
           </a:p>
           <a:p>
@@ -4485,14 +5782,14 @@
               </a:defRPr>
             </a:pPr>
             <a:r>
-              <a:t>Before digital table ordering</a:t>
-            </a:r>
-          </a:p>
-        </p:txBody>
-      </p:sp>
-      <p:sp>
-        <p:nvSpPr>
-          <p:cNvPr id="3" name="TextBox 2"/>
+              <a:t>Restaurants juggle too many systems</a:t>
+            </a:r>
+          </a:p>
+        </p:txBody>
+      </p:sp>
+      <p:sp>
+        <p:nvSpPr>
+          <p:cNvPr id="4" name="TextBox 3"/>
           <p:cNvSpPr txBox="1"/>
           <p:nvPr/>
         </p:nvSpPr>
@@ -4514,83 +5811,83 @@
           <a:p>
             <a:pPr>
               <a:spcAft>
-                <a:spcPts val="1000"/>
+                <a:spcPts val="800"/>
               </a:spcAft>
-              <a:defRPr sz="1800">
-                <a:solidFill>
-                  <a:srgbClr val="FFFFFF"/>
-                </a:solidFill>
-              </a:defRPr>
-            </a:pPr>
-            <a:r>
-              <a:t>Guests wait for staff to take orders — slow during rush hour</a:t>
+              <a:defRPr sz="1700">
+                <a:solidFill>
+                  <a:srgbClr val="FFFFFF"/>
+                </a:solidFill>
+              </a:defRPr>
+            </a:pPr>
+            <a:r>
+              <a:t>Guests wait to order — slow during rush</a:t>
             </a:r>
           </a:p>
           <a:p>
             <a:pPr>
               <a:spcAft>
-                <a:spcPts val="1000"/>
+                <a:spcPts val="800"/>
               </a:spcAft>
-              <a:defRPr sz="1800">
-                <a:solidFill>
-                  <a:srgbClr val="FFFFFF"/>
-                </a:solidFill>
-              </a:defRPr>
-            </a:pPr>
-            <a:r>
-              <a:t>Order mistakes from handwriting or miscommunication</a:t>
+              <a:defRPr sz="1700">
+                <a:solidFill>
+                  <a:srgbClr val="FFFFFF"/>
+                </a:solidFill>
+              </a:defRPr>
+            </a:pPr>
+            <a:r>
+              <a:t>Kitchen runs on paper chits and shouting</a:t>
             </a:r>
           </a:p>
           <a:p>
             <a:pPr>
               <a:spcAft>
-                <a:spcPts val="1000"/>
+                <a:spcPts val="800"/>
               </a:spcAft>
-              <a:defRPr sz="1800">
-                <a:solidFill>
-                  <a:srgbClr val="FFFFFF"/>
-                </a:solidFill>
-              </a:defRPr>
-            </a:pPr>
-            <a:r>
-              <a:t>No visibility on prep time — guests keep asking “where is my food?”</a:t>
+              <a:defRPr sz="1700">
+                <a:solidFill>
+                  <a:srgbClr val="FFFFFF"/>
+                </a:solidFill>
+              </a:defRPr>
+            </a:pPr>
+            <a:r>
+              <a:t>Swiggy, Zomato, and dine-in use different workflows</a:t>
             </a:r>
           </a:p>
           <a:p>
             <a:pPr>
               <a:spcAft>
-                <a:spcPts val="1000"/>
+                <a:spcPts val="800"/>
               </a:spcAft>
-              <a:defRPr sz="1800">
-                <a:solidFill>
-                  <a:srgbClr val="FFFFFF"/>
-                </a:solidFill>
-              </a:defRPr>
-            </a:pPr>
-            <a:r>
-              <a:t>Remote misuse: anyone with a saved link could order from outside</a:t>
+              <a:defRPr sz="1700">
+                <a:solidFill>
+                  <a:srgbClr val="FFFFFF"/>
+                </a:solidFill>
+              </a:defRPr>
+            </a:pPr>
+            <a:r>
+              <a:t>Remote QR misuse wastes food and kitchen time</a:t>
             </a:r>
           </a:p>
           <a:p>
             <a:pPr>
               <a:spcAft>
-                <a:spcPts val="1000"/>
+                <a:spcPts val="800"/>
               </a:spcAft>
-              <a:defRPr sz="1800">
-                <a:solidFill>
-                  <a:srgbClr val="FFFFFF"/>
-                </a:solidFill>
-              </a:defRPr>
-            </a:pPr>
-            <a:r>
-              <a:t>Cash/UPI collection at the end slows table turnover</a:t>
+              <a:defRPr sz="1700">
+                <a:solidFill>
+                  <a:srgbClr val="FFFFFF"/>
+                </a:solidFill>
+              </a:defRPr>
+            </a:pPr>
+            <a:r>
+              <a:t>Owners lack real-time revenue visibility</a:t>
             </a:r>
           </a:p>
         </p:txBody>
       </p:sp>
       <p:pic>
         <p:nvPicPr>
-          <p:cNvPr id="4" name="Picture 3" descr="10-staff-login.png"/>
+          <p:cNvPr id="5" name="Picture 4" descr="10-staff-login.png"/>
           <p:cNvPicPr>
             <a:picLocks noChangeAspect="1"/>
           </p:cNvPicPr>
@@ -4614,7 +5911,7 @@
       </p:pic>
       <p:sp>
         <p:nvSpPr>
-          <p:cNvPr id="5" name="TextBox 4"/>
+          <p:cNvPr id="6" name="TextBox 5"/>
           <p:cNvSpPr txBox="1"/>
           <p:nvPr/>
         </p:nvSpPr>
@@ -4642,7 +5939,7 @@
               </a:defRPr>
             </a:pPr>
             <a:r>
-              <a:t>TableTap · Smart Restaurant Ordering</a:t>
+              <a:t>TableTap · Complete Restaurant Platform</a:t>
             </a:r>
           </a:p>
         </p:txBody>
@@ -4661,7 +5958,7 @@
     <p:bg>
       <p:bgPr>
         <a:solidFill>
-          <a:srgbClr val="0F0F1A"/>
+          <a:srgbClr val="08080E"/>
         </a:solidFill>
         <a:effectLst/>
       </p:bgPr>
@@ -4675,7 +5972,50 @@
       <p:grpSpPr/>
       <p:sp>
         <p:nvSpPr>
-          <p:cNvPr id="2" name="TextBox 1"/>
+          <p:cNvPr id="2" name="Rectangle 1"/>
+          <p:cNvSpPr/>
+          <p:nvPr/>
+        </p:nvSpPr>
+        <p:spPr>
+          <a:xfrm>
+            <a:off x="0" y="0"/>
+            <a:ext cx="12191695" cy="73152"/>
+          </a:xfrm>
+          <a:prstGeom prst="rect">
+            <a:avLst/>
+          </a:prstGeom>
+          <a:solidFill>
+            <a:srgbClr val="F97316"/>
+          </a:solidFill>
+          <a:ln>
+            <a:noFill/>
+          </a:ln>
+        </p:spPr>
+        <p:style>
+          <a:lnRef idx="1">
+            <a:schemeClr val="accent1"/>
+          </a:lnRef>
+          <a:fillRef idx="3">
+            <a:schemeClr val="accent1"/>
+          </a:fillRef>
+          <a:effectRef idx="2">
+            <a:schemeClr val="accent1"/>
+          </a:effectRef>
+          <a:fontRef idx="minor">
+            <a:schemeClr val="lt1"/>
+          </a:fontRef>
+        </p:style>
+        <p:txBody>
+          <a:bodyPr rtlCol="0" anchor="ctr"/>
+          <a:lstStyle/>
+          <a:p>
+            <a:pPr algn="ctr"/>
+          </a:p>
+        </p:txBody>
+      </p:sp>
+      <p:sp>
+        <p:nvSpPr>
+          <p:cNvPr id="3" name="TextBox 2"/>
           <p:cNvSpPr txBox="1"/>
           <p:nvPr/>
         </p:nvSpPr>
@@ -4718,21 +6058,21 @@
               </a:defRPr>
             </a:pPr>
             <a:r>
-              <a:t>One QR on each table — guests order from their phone</a:t>
-            </a:r>
-          </a:p>
-        </p:txBody>
-      </p:sp>
-      <p:sp>
-        <p:nvSpPr>
-          <p:cNvPr id="3" name="TextBox 2"/>
+              <a:t>One QR per table — full-service in one app</a:t>
+            </a:r>
+          </a:p>
+        </p:txBody>
+      </p:sp>
+      <p:sp>
+        <p:nvSpPr>
+          <p:cNvPr id="4" name="TextBox 3"/>
           <p:cNvSpPr txBox="1"/>
           <p:nvPr/>
         </p:nvSpPr>
         <p:spPr>
           <a:xfrm>
             <a:off x="640080" y="1463040"/>
-            <a:ext cx="5669280" cy="4572000"/>
+            <a:ext cx="5486400" cy="4572000"/>
           </a:xfrm>
           <a:prstGeom prst="rect">
             <a:avLst/>
@@ -4747,83 +6087,98 @@
           <a:p>
             <a:pPr>
               <a:spcAft>
-                <a:spcPts val="1000"/>
+                <a:spcPts val="800"/>
               </a:spcAft>
-              <a:defRPr sz="1800">
-                <a:solidFill>
-                  <a:srgbClr val="FFFFFF"/>
-                </a:solidFill>
-              </a:defRPr>
-            </a:pPr>
-            <a:r>
-              <a:t>Customer scans QR → browses menu → places order instantly</a:t>
+              <a:defRPr sz="1700">
+                <a:solidFill>
+                  <a:srgbClr val="FFFFFF"/>
+                </a:solidFill>
+              </a:defRPr>
+            </a:pPr>
+            <a:r>
+              <a:t>Guest scans QR → orders from phone (no app download)</a:t>
             </a:r>
           </a:p>
           <a:p>
             <a:pPr>
               <a:spcAft>
-                <a:spcPts val="1000"/>
+                <a:spcPts val="800"/>
               </a:spcAft>
-              <a:defRPr sz="1800">
-                <a:solidFill>
-                  <a:srgbClr val="FFFFFF"/>
-                </a:solidFill>
-              </a:defRPr>
-            </a:pPr>
-            <a:r>
-              <a:t>Kitchen sees orders on a live staff dashboard with timers</a:t>
+              <a:defRPr sz="1700">
+                <a:solidFill>
+                  <a:srgbClr val="FFFFFF"/>
+                </a:solidFill>
+              </a:defRPr>
+            </a:pPr>
+            <a:r>
+              <a:t>Kitchen sees all channels on one board (+ optional KDS)</a:t>
             </a:r>
           </a:p>
           <a:p>
             <a:pPr>
               <a:spcAft>
-                <a:spcPts val="1000"/>
+                <a:spcPts val="800"/>
               </a:spcAft>
-              <a:defRPr sz="1800">
-                <a:solidFill>
-                  <a:srgbClr val="FFFFFF"/>
-                </a:solidFill>
-              </a:defRPr>
-            </a:pPr>
-            <a:r>
-              <a:t>Role-based staff: Cook, Server, Manager, Owner</a:t>
+              <a:defRPr sz="1700">
+                <a:solidFill>
+                  <a:srgbClr val="FFFFFF"/>
+                </a:solidFill>
+              </a:defRPr>
+            </a:pPr>
+            <a:r>
+              <a:t>Staff dashboard with timers, alerts, payments</a:t>
             </a:r>
           </a:p>
           <a:p>
             <a:pPr>
               <a:spcAft>
-                <a:spcPts val="1000"/>
+                <a:spcPts val="800"/>
               </a:spcAft>
-              <a:defRPr sz="1800">
-                <a:solidFill>
-                  <a:srgbClr val="FFFFFF"/>
-                </a:solidFill>
-              </a:defRPr>
-            </a:pPr>
-            <a:r>
-              <a:t>PhonePe QR or offline payment — table unlocks after staff confirms</a:t>
+              <a:defRPr sz="1700">
+                <a:solidFill>
+                  <a:srgbClr val="FFFFFF"/>
+                </a:solidFill>
+              </a:defRPr>
+            </a:pPr>
+            <a:r>
+              <a:t>Takeaway &amp; delivery without a second POS</a:t>
             </a:r>
           </a:p>
           <a:p>
             <a:pPr>
               <a:spcAft>
-                <a:spcPts val="1000"/>
+                <a:spcPts val="800"/>
               </a:spcAft>
-              <a:defRPr sz="1800">
-                <a:solidFill>
-                  <a:srgbClr val="FFFFFF"/>
-                </a:solidFill>
-              </a:defRPr>
-            </a:pPr>
-            <a:r>
-              <a:t>Spin wheel &amp; rewards while guests wait</a:t>
+              <a:defRPr sz="1700">
+                <a:solidFill>
+                  <a:srgbClr val="FFFFFF"/>
+                </a:solidFill>
+              </a:defRPr>
+            </a:pPr>
+            <a:r>
+              <a:t>Swiggy/Zomato orders flow in automatically</a:t>
+            </a:r>
+          </a:p>
+          <a:p>
+            <a:pPr>
+              <a:spcAft>
+                <a:spcPts val="800"/>
+              </a:spcAft>
+              <a:defRPr sz="1700">
+                <a:solidFill>
+                  <a:srgbClr val="FFFFFF"/>
+                </a:solidFill>
+              </a:defRPr>
+            </a:pPr>
+            <a:r>
+              <a:t>Owner controls menu, QR, reports, integrations</a:t>
             </a:r>
           </a:p>
         </p:txBody>
       </p:sp>
       <p:pic>
         <p:nvPicPr>
-          <p:cNvPr id="4" name="Picture 3" descr="02-customer-menu.png"/>
+          <p:cNvPr id="5" name="Picture 4" descr="02-customer-menu.png"/>
           <p:cNvPicPr>
             <a:picLocks noChangeAspect="1"/>
           </p:cNvPicPr>
@@ -4837,7 +6192,7 @@
         </p:blipFill>
         <p:spPr>
           <a:xfrm>
-            <a:off x="6492240" y="1234440"/>
+            <a:off x="6400800" y="1234440"/>
             <a:ext cx="4206240" cy="9116781"/>
           </a:xfrm>
           <a:prstGeom prst="rect">
@@ -4847,7 +6202,7 @@
       </p:pic>
       <p:sp>
         <p:nvSpPr>
-          <p:cNvPr id="5" name="TextBox 4"/>
+          <p:cNvPr id="6" name="TextBox 5"/>
           <p:cNvSpPr txBox="1"/>
           <p:nvPr/>
         </p:nvSpPr>
@@ -4875,7 +6230,7 @@
               </a:defRPr>
             </a:pPr>
             <a:r>
-              <a:t>TableTap · Smart Restaurant Ordering</a:t>
+              <a:t>TableTap · Complete Restaurant Platform</a:t>
             </a:r>
           </a:p>
         </p:txBody>
@@ -4894,7 +6249,7 @@
     <p:bg>
       <p:bgPr>
         <a:solidFill>
-          <a:srgbClr val="0F0F1A"/>
+          <a:srgbClr val="08080E"/>
         </a:solidFill>
         <a:effectLst/>
       </p:bgPr>
@@ -4908,7 +6263,50 @@
       <p:grpSpPr/>
       <p:sp>
         <p:nvSpPr>
-          <p:cNvPr id="2" name="TextBox 1"/>
+          <p:cNvPr id="2" name="Rectangle 1"/>
+          <p:cNvSpPr/>
+          <p:nvPr/>
+        </p:nvSpPr>
+        <p:spPr>
+          <a:xfrm>
+            <a:off x="0" y="0"/>
+            <a:ext cx="12191695" cy="73152"/>
+          </a:xfrm>
+          <a:prstGeom prst="rect">
+            <a:avLst/>
+          </a:prstGeom>
+          <a:solidFill>
+            <a:srgbClr val="F97316"/>
+          </a:solidFill>
+          <a:ln>
+            <a:noFill/>
+          </a:ln>
+        </p:spPr>
+        <p:style>
+          <a:lnRef idx="1">
+            <a:schemeClr val="accent1"/>
+          </a:lnRef>
+          <a:fillRef idx="3">
+            <a:schemeClr val="accent1"/>
+          </a:fillRef>
+          <a:effectRef idx="2">
+            <a:schemeClr val="accent1"/>
+          </a:effectRef>
+          <a:fontRef idx="minor">
+            <a:schemeClr val="lt1"/>
+          </a:fontRef>
+        </p:style>
+        <p:txBody>
+          <a:bodyPr rtlCol="0" anchor="ctr"/>
+          <a:lstStyle/>
+          <a:p>
+            <a:pPr algn="ctr"/>
+          </a:p>
+        </p:txBody>
+      </p:sp>
+      <p:sp>
+        <p:nvSpPr>
+          <p:cNvPr id="3" name="TextBox 2"/>
           <p:cNvSpPr txBox="1"/>
           <p:nvPr/>
         </p:nvSpPr>
@@ -4936,7 +6334,7 @@
               </a:defRPr>
             </a:pPr>
             <a:r>
-              <a:t>Customer experience</a:t>
+              <a:t>Customer journey</a:t>
             </a:r>
           </a:p>
           <a:p>
@@ -4951,14 +6349,14 @@
               </a:defRPr>
             </a:pPr>
             <a:r>
-              <a:t>Simple flow — no app download, no login</a:t>
-            </a:r>
-          </a:p>
-        </p:txBody>
-      </p:sp>
-      <p:sp>
-        <p:nvSpPr>
-          <p:cNvPr id="3" name="TextBox 2"/>
+              <a:t>Secure check-in → order → pay → rewards</a:t>
+            </a:r>
+          </a:p>
+        </p:txBody>
+      </p:sp>
+      <p:sp>
+        <p:nvSpPr>
+          <p:cNvPr id="4" name="TextBox 3"/>
           <p:cNvSpPr txBox="1"/>
           <p:nvPr/>
         </p:nvSpPr>
@@ -4980,98 +6378,98 @@
           <a:p>
             <a:pPr>
               <a:spcAft>
-                <a:spcPts val="1000"/>
+                <a:spcPts val="800"/>
               </a:spcAft>
-              <a:defRPr sz="1800">
-                <a:solidFill>
-                  <a:srgbClr val="FFFFFF"/>
-                </a:solidFill>
-              </a:defRPr>
-            </a:pPr>
-            <a:r>
-              <a:t>① Scan QR on the table (secure check-in)</a:t>
+              <a:defRPr sz="1700">
+                <a:solidFill>
+                  <a:srgbClr val="FFFFFF"/>
+                </a:solidFill>
+              </a:defRPr>
+            </a:pPr>
+            <a:r>
+              <a:t>① Staff opens table when guests are seated</a:t>
             </a:r>
           </a:p>
           <a:p>
             <a:pPr>
               <a:spcAft>
-                <a:spcPts val="1000"/>
+                <a:spcPts val="800"/>
               </a:spcAft>
-              <a:defRPr sz="1800">
-                <a:solidFill>
-                  <a:srgbClr val="FFFFFF"/>
-                </a:solidFill>
-              </a:defRPr>
-            </a:pPr>
-            <a:r>
-              <a:t>② Browse menu by category — expand/collapse sections</a:t>
+              <a:defRPr sz="1700">
+                <a:solidFill>
+                  <a:srgbClr val="FFFFFF"/>
+                </a:solidFill>
+              </a:defRPr>
+            </a:pPr>
+            <a:r>
+              <a:t>② Guest scans QR and completes check-in</a:t>
             </a:r>
           </a:p>
           <a:p>
             <a:pPr>
               <a:spcAft>
-                <a:spcPts val="1000"/>
+                <a:spcPts val="800"/>
               </a:spcAft>
-              <a:defRPr sz="1800">
-                <a:solidFill>
-                  <a:srgbClr val="FFFFFF"/>
-                </a:solidFill>
-              </a:defRPr>
-            </a:pPr>
-            <a:r>
-              <a:t>③ Add items to cart and place order</a:t>
+              <a:defRPr sz="1700">
+                <a:solidFill>
+                  <a:srgbClr val="FFFFFF"/>
+                </a:solidFill>
+              </a:defRPr>
+            </a:pPr>
+            <a:r>
+              <a:t>③ Browse menu, add to cart, place order</a:t>
             </a:r>
           </a:p>
           <a:p>
             <a:pPr>
               <a:spcAft>
-                <a:spcPts val="1000"/>
+                <a:spcPts val="800"/>
               </a:spcAft>
-              <a:defRPr sz="1800">
-                <a:solidFill>
-                  <a:srgbClr val="FFFFFF"/>
-                </a:solidFill>
-              </a:defRPr>
-            </a:pPr>
-            <a:r>
-              <a:t>④ Track order status &amp; countdown timer</a:t>
+              <a:defRPr sz="1700">
+                <a:solidFill>
+                  <a:srgbClr val="FFFFFF"/>
+                </a:solidFill>
+              </a:defRPr>
+            </a:pPr>
+            <a:r>
+              <a:t>④ Track prep countdown on phone</a:t>
             </a:r>
           </a:p>
           <a:p>
             <a:pPr>
               <a:spcAft>
-                <a:spcPts val="1000"/>
+                <a:spcPts val="800"/>
               </a:spcAft>
-              <a:defRPr sz="1800">
-                <a:solidFill>
-                  <a:srgbClr val="FFFFFF"/>
-                </a:solidFill>
-              </a:defRPr>
-            </a:pPr>
-            <a:r>
-              <a:t>⑤ Pay via PhonePe QR or alert staff</a:t>
+              <a:defRPr sz="1700">
+                <a:solidFill>
+                  <a:srgbClr val="FFFFFF"/>
+                </a:solidFill>
+              </a:defRPr>
+            </a:pPr>
+            <a:r>
+              <a:t>⑤ Pay via PhonePe QR or alert server</a:t>
             </a:r>
           </a:p>
           <a:p>
             <a:pPr>
               <a:spcAft>
-                <a:spcPts val="1000"/>
+                <a:spcPts val="800"/>
               </a:spcAft>
-              <a:defRPr sz="1800">
-                <a:solidFill>
-                  <a:srgbClr val="FFFFFF"/>
-                </a:solidFill>
-              </a:defRPr>
-            </a:pPr>
-            <a:r>
-              <a:t>⑥ Spin the reward wheel while waiting</a:t>
+              <a:defRPr sz="1700">
+                <a:solidFill>
+                  <a:srgbClr val="FFFFFF"/>
+                </a:solidFill>
+              </a:defRPr>
+            </a:pPr>
+            <a:r>
+              <a:t>⑥ Spin reward wheel while waiting</a:t>
             </a:r>
           </a:p>
         </p:txBody>
       </p:sp>
       <p:pic>
         <p:nvPicPr>
-          <p:cNvPr id="4" name="Picture 3" descr="03-customer-menu-scroll.png"/>
+          <p:cNvPr id="5" name="Picture 4" descr="03-customer-menu-scroll.png"/>
           <p:cNvPicPr>
             <a:picLocks noChangeAspect="1"/>
           </p:cNvPicPr>
@@ -5095,7 +6493,7 @@
       </p:pic>
       <p:sp>
         <p:nvSpPr>
-          <p:cNvPr id="5" name="TextBox 4"/>
+          <p:cNvPr id="6" name="TextBox 5"/>
           <p:cNvSpPr txBox="1"/>
           <p:nvPr/>
         </p:nvSpPr>
@@ -5123,7 +6521,7 @@
               </a:defRPr>
             </a:pPr>
             <a:r>
-              <a:t>TableTap · Smart Restaurant Ordering</a:t>
+              <a:t>TableTap · Complete Restaurant Platform</a:t>
             </a:r>
           </a:p>
         </p:txBody>
@@ -5142,7 +6540,7 @@
     <p:bg>
       <p:bgPr>
         <a:solidFill>
-          <a:srgbClr val="0F0F1A"/>
+          <a:srgbClr val="08080E"/>
         </a:solidFill>
         <a:effectLst/>
       </p:bgPr>
@@ -5156,7 +6554,50 @@
       <p:grpSpPr/>
       <p:sp>
         <p:nvSpPr>
-          <p:cNvPr id="2" name="TextBox 1"/>
+          <p:cNvPr id="2" name="Rectangle 1"/>
+          <p:cNvSpPr/>
+          <p:nvPr/>
+        </p:nvSpPr>
+        <p:spPr>
+          <a:xfrm>
+            <a:off x="0" y="0"/>
+            <a:ext cx="12191695" cy="73152"/>
+          </a:xfrm>
+          <a:prstGeom prst="rect">
+            <a:avLst/>
+          </a:prstGeom>
+          <a:solidFill>
+            <a:srgbClr val="F97316"/>
+          </a:solidFill>
+          <a:ln>
+            <a:noFill/>
+          </a:ln>
+        </p:spPr>
+        <p:style>
+          <a:lnRef idx="1">
+            <a:schemeClr val="accent1"/>
+          </a:lnRef>
+          <a:fillRef idx="3">
+            <a:schemeClr val="accent1"/>
+          </a:fillRef>
+          <a:effectRef idx="2">
+            <a:schemeClr val="accent1"/>
+          </a:effectRef>
+          <a:fontRef idx="minor">
+            <a:schemeClr val="lt1"/>
+          </a:fontRef>
+        </p:style>
+        <p:txBody>
+          <a:bodyPr rtlCol="0" anchor="ctr"/>
+          <a:lstStyle/>
+          <a:p>
+            <a:pPr algn="ctr"/>
+          </a:p>
+        </p:txBody>
+      </p:sp>
+      <p:sp>
+        <p:nvSpPr>
+          <p:cNvPr id="3" name="TextBox 2"/>
           <p:cNvSpPr txBox="1"/>
           <p:nvPr/>
         </p:nvSpPr>
@@ -5199,14 +6640,14 @@
               </a:defRPr>
             </a:pPr>
             <a:r>
-              <a:t>Saved links cannot be used to order from home</a:t>
-            </a:r>
-          </a:p>
-        </p:txBody>
-      </p:sp>
-      <p:sp>
-        <p:nvSpPr>
-          <p:cNvPr id="3" name="TextBox 2"/>
+              <a:t>Saved links cannot order from home</a:t>
+            </a:r>
+          </a:p>
+        </p:txBody>
+      </p:sp>
+      <p:sp>
+        <p:nvSpPr>
+          <p:cNvPr id="4" name="TextBox 3"/>
           <p:cNvSpPr txBox="1"/>
           <p:nvPr/>
         </p:nvSpPr>
@@ -5228,54 +6669,54 @@
           <a:p>
             <a:pPr>
               <a:spcAft>
-                <a:spcPts val="1000"/>
+                <a:spcPts val="800"/>
               </a:spcAft>
-              <a:defRPr sz="1800">
-                <a:solidFill>
-                  <a:srgbClr val="FFFFFF"/>
-                </a:solidFill>
-              </a:defRPr>
-            </a:pPr>
-            <a:r>
-              <a:t>Staff opens the table when guests are seated</a:t>
+              <a:defRPr sz="1700">
+                <a:solidFill>
+                  <a:srgbClr val="FFFFFF"/>
+                </a:solidFill>
+              </a:defRPr>
+            </a:pPr>
+            <a:r>
+              <a:t>Table must be opened by staff before ordering</a:t>
             </a:r>
           </a:p>
           <a:p>
             <a:pPr>
               <a:spcAft>
-                <a:spcPts val="1000"/>
+                <a:spcPts val="800"/>
               </a:spcAft>
-              <a:defRPr sz="1800">
-                <a:solidFill>
-                  <a:srgbClr val="FFFFFF"/>
-                </a:solidFill>
-              </a:defRPr>
-            </a:pPr>
-            <a:r>
-              <a:t>QR check-in verifies the guest is dining in</a:t>
+              <a:defRPr sz="1700">
+                <a:solidFill>
+                  <a:srgbClr val="FFFFFF"/>
+                </a:solidFill>
+              </a:defRPr>
+            </a:pPr>
+            <a:r>
+              <a:t>Rotating check-in + session limits per table</a:t>
             </a:r>
           </a:p>
           <a:p>
             <a:pPr>
               <a:spcAft>
-                <a:spcPts val="1000"/>
+                <a:spcPts val="800"/>
               </a:spcAft>
-              <a:defRPr sz="1800">
-                <a:solidFill>
-                  <a:srgbClr val="FFFFFF"/>
-                </a:solidFill>
-              </a:defRPr>
-            </a:pPr>
-            <a:r>
-              <a:t>Ordering closes automatically when the table clears</a:t>
+              <a:defRPr sz="1700">
+                <a:solidFill>
+                  <a:srgbClr val="FFFFFF"/>
+                </a:solidFill>
+              </a:defRPr>
+            </a:pPr>
+            <a:r>
+              <a:t>Table closes when guests leave or bill is paid</a:t>
             </a:r>
           </a:p>
           <a:p>
             <a:pPr>
               <a:spcAft>
-                <a:spcPts val="1000"/>
+                <a:spcPts val="800"/>
               </a:spcAft>
-              <a:defRPr sz="1800">
+              <a:defRPr sz="1700">
                 <a:solidFill>
                   <a:srgbClr val="FFFFFF"/>
                 </a:solidFill>
@@ -5289,7 +6730,7 @@
       </p:sp>
       <p:pic>
         <p:nvPicPr>
-          <p:cNvPr id="4" name="Picture 3" descr="02-customer-menu.png"/>
+          <p:cNvPr id="5" name="Picture 4" descr="02-customer-menu.png"/>
           <p:cNvPicPr>
             <a:picLocks noChangeAspect="1"/>
           </p:cNvPicPr>
@@ -5313,7 +6754,7 @@
       </p:pic>
       <p:sp>
         <p:nvSpPr>
-          <p:cNvPr id="5" name="TextBox 4"/>
+          <p:cNvPr id="6" name="TextBox 5"/>
           <p:cNvSpPr txBox="1"/>
           <p:nvPr/>
         </p:nvSpPr>
@@ -5341,7 +6782,7 @@
               </a:defRPr>
             </a:pPr>
             <a:r>
-              <a:t>TableTap · Smart Restaurant Ordering</a:t>
+              <a:t>TableTap · Complete Restaurant Platform</a:t>
             </a:r>
           </a:p>
         </p:txBody>
@@ -5360,7 +6801,7 @@
     <p:bg>
       <p:bgPr>
         <a:solidFill>
-          <a:srgbClr val="0F0F1A"/>
+          <a:srgbClr val="08080E"/>
         </a:solidFill>
         <a:effectLst/>
       </p:bgPr>
@@ -5374,7 +6815,50 @@
       <p:grpSpPr/>
       <p:sp>
         <p:nvSpPr>
-          <p:cNvPr id="2" name="TextBox 1"/>
+          <p:cNvPr id="2" name="Rectangle 1"/>
+          <p:cNvSpPr/>
+          <p:nvPr/>
+        </p:nvSpPr>
+        <p:spPr>
+          <a:xfrm>
+            <a:off x="0" y="0"/>
+            <a:ext cx="12191695" cy="73152"/>
+          </a:xfrm>
+          <a:prstGeom prst="rect">
+            <a:avLst/>
+          </a:prstGeom>
+          <a:solidFill>
+            <a:srgbClr val="F97316"/>
+          </a:solidFill>
+          <a:ln>
+            <a:noFill/>
+          </a:ln>
+        </p:spPr>
+        <p:style>
+          <a:lnRef idx="1">
+            <a:schemeClr val="accent1"/>
+          </a:lnRef>
+          <a:fillRef idx="3">
+            <a:schemeClr val="accent1"/>
+          </a:fillRef>
+          <a:effectRef idx="2">
+            <a:schemeClr val="accent1"/>
+          </a:effectRef>
+          <a:fontRef idx="minor">
+            <a:schemeClr val="lt1"/>
+          </a:fontRef>
+        </p:style>
+        <p:txBody>
+          <a:bodyPr rtlCol="0" anchor="ctr"/>
+          <a:lstStyle/>
+          <a:p>
+            <a:pPr algn="ctr"/>
+          </a:p>
+        </p:txBody>
+      </p:sp>
+      <p:sp>
+        <p:nvSpPr>
+          <p:cNvPr id="3" name="TextBox 2"/>
           <p:cNvSpPr txBox="1"/>
           <p:nvPr/>
         </p:nvSpPr>
@@ -5417,14 +6901,14 @@
               </a:defRPr>
             </a:pPr>
             <a:r>
-              <a:t>Real-time control for your team</a:t>
-            </a:r>
-          </a:p>
-        </p:txBody>
-      </p:sp>
-      <p:sp>
-        <p:nvSpPr>
-          <p:cNvPr id="3" name="TextBox 2"/>
+              <a:t>Live operations for every role</a:t>
+            </a:r>
+          </a:p>
+        </p:txBody>
+      </p:sp>
+      <p:sp>
+        <p:nvSpPr>
+          <p:cNvPr id="4" name="TextBox 3"/>
           <p:cNvSpPr txBox="1"/>
           <p:nvPr/>
         </p:nvSpPr>
@@ -5446,9 +6930,9 @@
           <a:p>
             <a:pPr>
               <a:spcAft>
-                <a:spcPts val="1000"/>
+                <a:spcPts val="800"/>
               </a:spcAft>
-              <a:defRPr sz="1800">
+              <a:defRPr sz="1700">
                 <a:solidFill>
                   <a:srgbClr val="FFFFFF"/>
                 </a:solidFill>
@@ -5461,68 +6945,83 @@
           <a:p>
             <a:pPr>
               <a:spcAft>
-                <a:spcPts val="1000"/>
+                <a:spcPts val="800"/>
               </a:spcAft>
-              <a:defRPr sz="1800">
-                <a:solidFill>
-                  <a:srgbClr val="FFFFFF"/>
-                </a:solidFill>
-              </a:defRPr>
-            </a:pPr>
-            <a:r>
-              <a:t>Sound alerts for new orders and customer help requests</a:t>
+              <a:defRPr sz="1700">
+                <a:solidFill>
+                  <a:srgbClr val="FFFFFF"/>
+                </a:solidFill>
+              </a:defRPr>
+            </a:pPr>
+            <a:r>
+              <a:t>Sound alerts for new orders and help requests</a:t>
             </a:r>
           </a:p>
           <a:p>
             <a:pPr>
               <a:spcAft>
-                <a:spcPts val="1000"/>
+                <a:spcPts val="800"/>
               </a:spcAft>
-              <a:defRPr sz="1800">
-                <a:solidFill>
-                  <a:srgbClr val="FFFFFF"/>
-                </a:solidFill>
-              </a:defRPr>
-            </a:pPr>
-            <a:r>
-              <a:t>Mark items preparing → ready → served</a:t>
+              <a:defRPr sz="1700">
+                <a:solidFill>
+                  <a:srgbClr val="FFFFFF"/>
+                </a:solidFill>
+              </a:defRPr>
+            </a:pPr>
+            <a:r>
+              <a:t>Mark preparing → ready → served</a:t>
             </a:r>
           </a:p>
           <a:p>
             <a:pPr>
               <a:spcAft>
-                <a:spcPts val="1000"/>
+                <a:spcPts val="800"/>
               </a:spcAft>
-              <a:defRPr sz="1800">
-                <a:solidFill>
-                  <a:srgbClr val="FFFFFF"/>
-                </a:solidFill>
-              </a:defRPr>
-            </a:pPr>
-            <a:r>
-              <a:t>Mark out-of-stock items — customer is notified automatically</a:t>
+              <a:defRPr sz="1700">
+                <a:solidFill>
+                  <a:srgbClr val="FFFFFF"/>
+                </a:solidFill>
+              </a:defRPr>
+            </a:pPr>
+            <a:r>
+              <a:t>Open/close table ordering with one tap</a:t>
             </a:r>
           </a:p>
           <a:p>
             <a:pPr>
               <a:spcAft>
-                <a:spcPts val="1000"/>
+                <a:spcPts val="800"/>
               </a:spcAft>
-              <a:defRPr sz="1800">
-                <a:solidFill>
-                  <a:srgbClr val="FFFFFF"/>
-                </a:solidFill>
-              </a:defRPr>
-            </a:pPr>
-            <a:r>
-              <a:t>Open/close table ordering with one tap</a:t>
+              <a:defRPr sz="1700">
+                <a:solidFill>
+                  <a:srgbClr val="FFFFFF"/>
+                </a:solidFill>
+              </a:defRPr>
+            </a:pPr>
+            <a:r>
+              <a:t>Pending vs completed payments</a:t>
+            </a:r>
+          </a:p>
+          <a:p>
+            <a:pPr>
+              <a:spcAft>
+                <a:spcPts val="800"/>
+              </a:spcAft>
+              <a:defRPr sz="1700">
+                <a:solidFill>
+                  <a:srgbClr val="FFFFFF"/>
+                </a:solidFill>
+              </a:defRPr>
+            </a:pPr>
+            <a:r>
+              <a:t>Reprint thermal receipts (premium)</a:t>
             </a:r>
           </a:p>
         </p:txBody>
       </p:sp>
       <p:pic>
         <p:nvPicPr>
-          <p:cNvPr id="4" name="Picture 3" descr="04-staff-dashboard.png"/>
+          <p:cNvPr id="5" name="Picture 4" descr="04-staff-dashboard.png"/>
           <p:cNvPicPr>
             <a:picLocks noChangeAspect="1"/>
           </p:cNvPicPr>
@@ -5546,7 +7045,7 @@
       </p:pic>
       <p:sp>
         <p:nvSpPr>
-          <p:cNvPr id="5" name="TextBox 4"/>
+          <p:cNvPr id="6" name="TextBox 5"/>
           <p:cNvSpPr txBox="1"/>
           <p:nvPr/>
         </p:nvSpPr>
@@ -5574,7 +7073,7 @@
               </a:defRPr>
             </a:pPr>
             <a:r>
-              <a:t>TableTap · Smart Restaurant Ordering</a:t>
+              <a:t>TableTap · Complete Restaurant Platform</a:t>
             </a:r>
           </a:p>
         </p:txBody>
@@ -5593,7 +7092,7 @@
     <p:bg>
       <p:bgPr>
         <a:solidFill>
-          <a:srgbClr val="0F0F1A"/>
+          <a:srgbClr val="08080E"/>
         </a:solidFill>
         <a:effectLst/>
       </p:bgPr>
@@ -5607,7 +7106,50 @@
       <p:grpSpPr/>
       <p:sp>
         <p:nvSpPr>
-          <p:cNvPr id="2" name="TextBox 1"/>
+          <p:cNvPr id="2" name="Rectangle 1"/>
+          <p:cNvSpPr/>
+          <p:nvPr/>
+        </p:nvSpPr>
+        <p:spPr>
+          <a:xfrm>
+            <a:off x="0" y="0"/>
+            <a:ext cx="12191695" cy="73152"/>
+          </a:xfrm>
+          <a:prstGeom prst="rect">
+            <a:avLst/>
+          </a:prstGeom>
+          <a:solidFill>
+            <a:srgbClr val="F97316"/>
+          </a:solidFill>
+          <a:ln>
+            <a:noFill/>
+          </a:ln>
+        </p:spPr>
+        <p:style>
+          <a:lnRef idx="1">
+            <a:schemeClr val="accent1"/>
+          </a:lnRef>
+          <a:fillRef idx="3">
+            <a:schemeClr val="accent1"/>
+          </a:fillRef>
+          <a:effectRef idx="2">
+            <a:schemeClr val="accent1"/>
+          </a:effectRef>
+          <a:fontRef idx="minor">
+            <a:schemeClr val="lt1"/>
+          </a:fontRef>
+        </p:style>
+        <p:txBody>
+          <a:bodyPr rtlCol="0" anchor="ctr"/>
+          <a:lstStyle/>
+          <a:p>
+            <a:pPr algn="ctr"/>
+          </a:p>
+        </p:txBody>
+      </p:sp>
+      <p:sp>
+        <p:nvSpPr>
+          <p:cNvPr id="3" name="TextBox 2"/>
           <p:cNvSpPr txBox="1"/>
           <p:nvPr/>
         </p:nvSpPr>
@@ -5635,7 +7177,7 @@
               </a:defRPr>
             </a:pPr>
             <a:r>
-              <a:t>Table ordering control</a:t>
+              <a:t>Kitchen Display System</a:t>
             </a:r>
           </a:p>
           <a:p>
@@ -5650,38 +7192,250 @@
               </a:defRPr>
             </a:pPr>
             <a:r>
-              <a:t>Servers enable ordering only for seated guests</a:t>
-            </a:r>
-          </a:p>
-        </p:txBody>
-      </p:sp>
-      <p:pic>
-        <p:nvPicPr>
-          <p:cNvPr id="3" name="Picture 2" descr="05-table-ordering-panel.png"/>
-          <p:cNvPicPr>
-            <a:picLocks noChangeAspect="1"/>
-          </p:cNvPicPr>
-          <p:nvPr/>
-        </p:nvPicPr>
-        <p:blipFill>
-          <a:blip r:embed="rId2"/>
-          <a:stretch>
-            <a:fillRect/>
-          </a:stretch>
-        </p:blipFill>
-        <p:spPr>
-          <a:xfrm>
-            <a:off x="731520" y="1234440"/>
-            <a:ext cx="10789920" cy="4804886"/>
-          </a:xfrm>
-          <a:prstGeom prst="rect">
-            <a:avLst/>
-          </a:prstGeom>
-        </p:spPr>
-      </p:pic>
+              <a:t>Premium module — station-routed tickets</a:t>
+            </a:r>
+          </a:p>
+        </p:txBody>
+      </p:sp>
       <p:sp>
         <p:nvSpPr>
           <p:cNvPr id="4" name="TextBox 3"/>
+          <p:cNvSpPr txBox="1"/>
+          <p:nvPr/>
+        </p:nvSpPr>
+        <p:spPr>
+          <a:xfrm>
+            <a:off x="640080" y="1463040"/>
+            <a:ext cx="5303520" cy="4572000"/>
+          </a:xfrm>
+          <a:prstGeom prst="rect">
+            <a:avLst/>
+          </a:prstGeom>
+          <a:noFill/>
+        </p:spPr>
+        <p:txBody>
+          <a:bodyPr wrap="square">
+            <a:spAutoFit/>
+          </a:bodyPr>
+          <a:lstStyle/>
+          <a:p>
+            <a:pPr>
+              <a:spcAft>
+                <a:spcPts val="800"/>
+              </a:spcAft>
+              <a:defRPr sz="1700">
+                <a:solidFill>
+                  <a:srgbClr val="FFFFFF"/>
+                </a:solidFill>
+              </a:defRPr>
+            </a:pPr>
+            <a:r>
+              <a:t>Routes items to Hot Kitchen, Grill, Bar, Cold</a:t>
+            </a:r>
+          </a:p>
+          <a:p>
+            <a:pPr>
+              <a:spcAft>
+                <a:spcPts val="800"/>
+              </a:spcAft>
+              <a:defRPr sz="1700">
+                <a:solidFill>
+                  <a:srgbClr val="FFFFFF"/>
+                </a:solidFill>
+              </a:defRPr>
+            </a:pPr>
+            <a:r>
+              <a:t>Large-format UI designed for cooks</a:t>
+            </a:r>
+          </a:p>
+          <a:p>
+            <a:pPr>
+              <a:spcAft>
+                <a:spcPts val="800"/>
+              </a:spcAft>
+              <a:defRPr sz="1700">
+                <a:solidFill>
+                  <a:srgbClr val="FFFFFF"/>
+                </a:solidFill>
+              </a:defRPr>
+            </a:pPr>
+            <a:r>
+              <a:t>Same stream: dine-in, takeaway, Swiggy, Zomato</a:t>
+            </a:r>
+          </a:p>
+          <a:p>
+            <a:pPr>
+              <a:spcAft>
+                <a:spcPts val="800"/>
+              </a:spcAft>
+              <a:defRPr sz="1700">
+                <a:solidFill>
+                  <a:srgbClr val="FFFFFF"/>
+                </a:solidFill>
+              </a:defRPr>
+            </a:pPr>
+            <a:r>
+              <a:t>Optional auto-print kitchen chits (Bluetooth)</a:t>
+            </a:r>
+          </a:p>
+          <a:p>
+            <a:pPr>
+              <a:spcAft>
+                <a:spcPts val="800"/>
+              </a:spcAft>
+              <a:defRPr sz="1700">
+                <a:solidFill>
+                  <a:srgbClr val="FFFFFF"/>
+                </a:solidFill>
+              </a:defRPr>
+            </a:pPr>
+            <a:r>
+              <a:t>Mark ready → pushes status to aggregators</a:t>
+            </a:r>
+          </a:p>
+        </p:txBody>
+      </p:sp>
+      <p:sp>
+        <p:nvSpPr>
+          <p:cNvPr id="5" name="Rounded Rectangle 4"/>
+          <p:cNvSpPr/>
+          <p:nvPr/>
+        </p:nvSpPr>
+        <p:spPr>
+          <a:xfrm>
+            <a:off x="6400800" y="1371600"/>
+            <a:ext cx="4572000" cy="1097280"/>
+          </a:xfrm>
+          <a:prstGeom prst="roundRect">
+            <a:avLst/>
+          </a:prstGeom>
+          <a:solidFill>
+            <a:srgbClr val="161622"/>
+          </a:solidFill>
+          <a:ln>
+            <a:solidFill>
+              <a:srgbClr val="373748"/>
+            </a:solidFill>
+          </a:ln>
+        </p:spPr>
+        <p:style>
+          <a:lnRef idx="1">
+            <a:schemeClr val="accent1"/>
+          </a:lnRef>
+          <a:fillRef idx="3">
+            <a:schemeClr val="accent1"/>
+          </a:fillRef>
+          <a:effectRef idx="2">
+            <a:schemeClr val="accent1"/>
+          </a:effectRef>
+          <a:fontRef idx="minor">
+            <a:schemeClr val="lt1"/>
+          </a:fontRef>
+        </p:style>
+        <p:txBody>
+          <a:bodyPr rtlCol="0" anchor="ctr" lIns="137160"/>
+          <a:lstStyle/>
+          <a:p>
+            <a:pPr algn="ctr">
+              <a:defRPr sz="1600" b="1">
+                <a:solidFill>
+                  <a:srgbClr val="FFFFFF"/>
+                </a:solidFill>
+              </a:defRPr>
+            </a:pPr>
+            <a:r>
+              <a:t>Enable: kds</a:t>
+            </a:r>
+          </a:p>
+          <a:p>
+            <a:pPr>
+              <a:spcBef>
+                <a:spcPts val="600"/>
+              </a:spcBef>
+              <a:defRPr sz="1100">
+                <a:solidFill>
+                  <a:srgbClr val="A1A1AA"/>
+                </a:solidFill>
+              </a:defRPr>
+            </a:pPr>
+            <a:r>
+              <a:t>Super admin or CLI — no redeploy</a:t>
+            </a:r>
+          </a:p>
+        </p:txBody>
+      </p:sp>
+      <p:sp>
+        <p:nvSpPr>
+          <p:cNvPr id="6" name="Rounded Rectangle 5"/>
+          <p:cNvSpPr/>
+          <p:nvPr/>
+        </p:nvSpPr>
+        <p:spPr>
+          <a:xfrm>
+            <a:off x="6400800" y="2743200"/>
+            <a:ext cx="4572000" cy="1097280"/>
+          </a:xfrm>
+          <a:prstGeom prst="roundRect">
+            <a:avLst/>
+          </a:prstGeom>
+          <a:solidFill>
+            <a:srgbClr val="161622"/>
+          </a:solidFill>
+          <a:ln>
+            <a:solidFill>
+              <a:srgbClr val="373748"/>
+            </a:solidFill>
+          </a:ln>
+        </p:spPr>
+        <p:style>
+          <a:lnRef idx="1">
+            <a:schemeClr val="accent1"/>
+          </a:lnRef>
+          <a:fillRef idx="3">
+            <a:schemeClr val="accent1"/>
+          </a:fillRef>
+          <a:effectRef idx="2">
+            <a:schemeClr val="accent1"/>
+          </a:effectRef>
+          <a:fontRef idx="minor">
+            <a:schemeClr val="lt1"/>
+          </a:fontRef>
+        </p:style>
+        <p:txBody>
+          <a:bodyPr rtlCol="0" anchor="ctr" lIns="137160"/>
+          <a:lstStyle/>
+          <a:p>
+            <a:pPr algn="ctr">
+              <a:defRPr sz="1600" b="1">
+                <a:solidFill>
+                  <a:srgbClr val="FFFFFF"/>
+                </a:solidFill>
+              </a:defRPr>
+            </a:pPr>
+            <a:r>
+              <a:t>Route: /kitchen</a:t>
+            </a:r>
+          </a:p>
+          <a:p>
+            <a:pPr>
+              <a:spcBef>
+                <a:spcPts val="600"/>
+              </a:spcBef>
+              <a:defRPr sz="1100">
+                <a:solidFill>
+                  <a:srgbClr val="A1A1AA"/>
+                </a:solidFill>
+              </a:defRPr>
+            </a:pPr>
+            <a:r>
+              <a:t>Cooks auto-redirect when enabled</a:t>
+            </a:r>
+          </a:p>
+        </p:txBody>
+      </p:sp>
+      <p:sp>
+        <p:nvSpPr>
+          <p:cNvPr id="7" name="TextBox 6"/>
           <p:cNvSpPr txBox="1"/>
           <p:nvPr/>
         </p:nvSpPr>
@@ -5709,7 +7463,7 @@
               </a:defRPr>
             </a:pPr>
             <a:r>
-              <a:t>TableTap · Smart Restaurant Ordering</a:t>
+              <a:t>TableTap · Complete Restaurant Platform</a:t>
             </a:r>
           </a:p>
         </p:txBody>
@@ -5728,7 +7482,7 @@
     <p:bg>
       <p:bgPr>
         <a:solidFill>
-          <a:srgbClr val="0F0F1A"/>
+          <a:srgbClr val="08080E"/>
         </a:solidFill>
         <a:effectLst/>
       </p:bgPr>
@@ -5742,7 +7496,50 @@
       <p:grpSpPr/>
       <p:sp>
         <p:nvSpPr>
-          <p:cNvPr id="2" name="TextBox 1"/>
+          <p:cNvPr id="2" name="Rectangle 1"/>
+          <p:cNvSpPr/>
+          <p:nvPr/>
+        </p:nvSpPr>
+        <p:spPr>
+          <a:xfrm>
+            <a:off x="0" y="0"/>
+            <a:ext cx="12191695" cy="73152"/>
+          </a:xfrm>
+          <a:prstGeom prst="rect">
+            <a:avLst/>
+          </a:prstGeom>
+          <a:solidFill>
+            <a:srgbClr val="F97316"/>
+          </a:solidFill>
+          <a:ln>
+            <a:noFill/>
+          </a:ln>
+        </p:spPr>
+        <p:style>
+          <a:lnRef idx="1">
+            <a:schemeClr val="accent1"/>
+          </a:lnRef>
+          <a:fillRef idx="3">
+            <a:schemeClr val="accent1"/>
+          </a:fillRef>
+          <a:effectRef idx="2">
+            <a:schemeClr val="accent1"/>
+          </a:effectRef>
+          <a:fontRef idx="minor">
+            <a:schemeClr val="lt1"/>
+          </a:fontRef>
+        </p:style>
+        <p:txBody>
+          <a:bodyPr rtlCol="0" anchor="ctr"/>
+          <a:lstStyle/>
+          <a:p>
+            <a:pPr algn="ctr"/>
+          </a:p>
+        </p:txBody>
+      </p:sp>
+      <p:sp>
+        <p:nvSpPr>
+          <p:cNvPr id="3" name="TextBox 2"/>
           <p:cNvSpPr txBox="1"/>
           <p:nvPr/>
         </p:nvSpPr>
@@ -5770,7 +7567,7 @@
               </a:defRPr>
             </a:pPr>
             <a:r>
-              <a:t>Payments made simple</a:t>
+              <a:t>Floor plan &amp; remote orders</a:t>
             </a:r>
           </a:p>
           <a:p>
@@ -5785,112 +7582,221 @@
               </a:defRPr>
             </a:pPr>
             <a:r>
-              <a:t>Pending vs completed — revenue only when paid</a:t>
-            </a:r>
-          </a:p>
-        </p:txBody>
-      </p:sp>
-      <p:sp>
-        <p:nvSpPr>
-          <p:cNvPr id="3" name="TextBox 2"/>
-          <p:cNvSpPr txBox="1"/>
-          <p:nvPr/>
-        </p:nvSpPr>
-        <p:spPr>
-          <a:xfrm>
-            <a:off x="640080" y="1463040"/>
-            <a:ext cx="5303520" cy="4572000"/>
-          </a:xfrm>
-          <a:prstGeom prst="rect">
-            <a:avLst/>
-          </a:prstGeom>
-          <a:noFill/>
-        </p:spPr>
-        <p:txBody>
-          <a:bodyPr wrap="square">
-            <a:spAutoFit/>
-          </a:bodyPr>
-          <a:lstStyle/>
-          <a:p>
-            <a:pPr>
-              <a:spcAft>
-                <a:spcPts val="1000"/>
-              </a:spcAft>
-              <a:defRPr sz="1800">
-                <a:solidFill>
-                  <a:srgbClr val="FFFFFF"/>
-                </a:solidFill>
-              </a:defRPr>
-            </a:pPr>
-            <a:r>
-              <a:t>Customer taps Pay → PhonePe QR on screen (if configured)</a:t>
-            </a:r>
-          </a:p>
-          <a:p>
-            <a:pPr>
-              <a:spcAft>
-                <a:spcPts val="1000"/>
-              </a:spcAft>
-              <a:defRPr sz="1800">
-                <a:solidFill>
-                  <a:srgbClr val="FFFFFF"/>
-                </a:solidFill>
-              </a:defRPr>
-            </a:pPr>
-            <a:r>
-              <a:t>Or alerts server for cash/UPI at the table</a:t>
-            </a:r>
-          </a:p>
-          <a:p>
-            <a:pPr>
-              <a:spcAft>
-                <a:spcPts val="1000"/>
-              </a:spcAft>
-              <a:defRPr sz="1800">
-                <a:solidFill>
-                  <a:srgbClr val="FFFFFF"/>
-                </a:solidFill>
-              </a:defRPr>
-            </a:pPr>
-            <a:r>
-              <a:t>Staff marks bill as paid — table unlocks for new orders</a:t>
-            </a:r>
-          </a:p>
-          <a:p>
-            <a:pPr>
-              <a:spcAft>
-                <a:spcPts val="1000"/>
-              </a:spcAft>
-              <a:defRPr sz="1800">
-                <a:solidFill>
-                  <a:srgbClr val="FFFFFF"/>
-                </a:solidFill>
-              </a:defRPr>
-            </a:pPr>
-            <a:r>
-              <a:t>Pending Payments tab vs Completed Orders tab</a:t>
-            </a:r>
-          </a:p>
-          <a:p>
-            <a:pPr>
-              <a:spcAft>
-                <a:spcPts val="1000"/>
-              </a:spcAft>
-              <a:defRPr sz="1800">
-                <a:solidFill>
-                  <a:srgbClr val="FFFFFF"/>
-                </a:solidFill>
-              </a:defRPr>
-            </a:pPr>
-            <a:r>
-              <a:t>Revenue reports count only confirmed payments</a:t>
+              <a:t>Premium modules</a:t>
+            </a:r>
+          </a:p>
+        </p:txBody>
+      </p:sp>
+      <p:sp>
+        <p:nvSpPr>
+          <p:cNvPr id="4" name="Rounded Rectangle 3"/>
+          <p:cNvSpPr/>
+          <p:nvPr/>
+        </p:nvSpPr>
+        <p:spPr>
+          <a:xfrm>
+            <a:off x="731520" y="1463040"/>
+            <a:ext cx="5029200" cy="1371600"/>
+          </a:xfrm>
+          <a:prstGeom prst="roundRect">
+            <a:avLst/>
+          </a:prstGeom>
+          <a:solidFill>
+            <a:srgbClr val="161622"/>
+          </a:solidFill>
+          <a:ln>
+            <a:solidFill>
+              <a:srgbClr val="373748"/>
+            </a:solidFill>
+          </a:ln>
+        </p:spPr>
+        <p:style>
+          <a:lnRef idx="1">
+            <a:schemeClr val="accent1"/>
+          </a:lnRef>
+          <a:fillRef idx="3">
+            <a:schemeClr val="accent1"/>
+          </a:fillRef>
+          <a:effectRef idx="2">
+            <a:schemeClr val="accent1"/>
+          </a:effectRef>
+          <a:fontRef idx="minor">
+            <a:schemeClr val="lt1"/>
+          </a:fontRef>
+        </p:style>
+        <p:txBody>
+          <a:bodyPr rtlCol="0" anchor="ctr" lIns="137160"/>
+          <a:lstStyle/>
+          <a:p>
+            <a:pPr algn="ctr">
+              <a:defRPr sz="1600" b="1">
+                <a:solidFill>
+                  <a:srgbClr val="FFFFFF"/>
+                </a:solidFill>
+              </a:defRPr>
+            </a:pPr>
+            <a:r>
+              <a:t>Floor plan (floor_plan)</a:t>
+            </a:r>
+          </a:p>
+          <a:p>
+            <a:pPr>
+              <a:spcBef>
+                <a:spcPts val="600"/>
+              </a:spcBef>
+              <a:defRPr sz="1100">
+                <a:solidFill>
+                  <a:srgbClr val="A1A1AA"/>
+                </a:solidFill>
+              </a:defRPr>
+            </a:pPr>
+            <a:r>
+              <a:t>Visual table map, server assignment, live bill, seat timers</a:t>
+            </a:r>
+          </a:p>
+        </p:txBody>
+      </p:sp>
+      <p:sp>
+        <p:nvSpPr>
+          <p:cNvPr id="5" name="Rounded Rectangle 4"/>
+          <p:cNvSpPr/>
+          <p:nvPr/>
+        </p:nvSpPr>
+        <p:spPr>
+          <a:xfrm>
+            <a:off x="731520" y="3108960"/>
+            <a:ext cx="5029200" cy="1371600"/>
+          </a:xfrm>
+          <a:prstGeom prst="roundRect">
+            <a:avLst/>
+          </a:prstGeom>
+          <a:solidFill>
+            <a:srgbClr val="161622"/>
+          </a:solidFill>
+          <a:ln>
+            <a:solidFill>
+              <a:srgbClr val="373748"/>
+            </a:solidFill>
+          </a:ln>
+        </p:spPr>
+        <p:style>
+          <a:lnRef idx="1">
+            <a:schemeClr val="accent1"/>
+          </a:lnRef>
+          <a:fillRef idx="3">
+            <a:schemeClr val="accent1"/>
+          </a:fillRef>
+          <a:effectRef idx="2">
+            <a:schemeClr val="accent1"/>
+          </a:effectRef>
+          <a:fontRef idx="minor">
+            <a:schemeClr val="lt1"/>
+          </a:fontRef>
+        </p:style>
+        <p:txBody>
+          <a:bodyPr rtlCol="0" anchor="ctr" lIns="137160"/>
+          <a:lstStyle/>
+          <a:p>
+            <a:pPr algn="ctr">
+              <a:defRPr sz="1600" b="1">
+                <a:solidFill>
+                  <a:srgbClr val="FFFFFF"/>
+                </a:solidFill>
+              </a:defRPr>
+            </a:pPr>
+            <a:r>
+              <a:t>Remote orders (phone_orders)</a:t>
+            </a:r>
+          </a:p>
+          <a:p>
+            <a:pPr>
+              <a:spcBef>
+                <a:spcPts val="600"/>
+              </a:spcBef>
+              <a:defRPr sz="1100">
+                <a:solidFill>
+                  <a:srgbClr val="A1A1AA"/>
+                </a:solidFill>
+              </a:defRPr>
+            </a:pPr>
+            <a:r>
+              <a:t>Walk-in, takeaway, delivery — one kitchen board</a:t>
+            </a:r>
+          </a:p>
+        </p:txBody>
+      </p:sp>
+      <p:sp>
+        <p:nvSpPr>
+          <p:cNvPr id="6" name="Rounded Rectangle 5"/>
+          <p:cNvSpPr/>
+          <p:nvPr/>
+        </p:nvSpPr>
+        <p:spPr>
+          <a:xfrm>
+            <a:off x="731520" y="4754880"/>
+            <a:ext cx="5029200" cy="914400"/>
+          </a:xfrm>
+          <a:prstGeom prst="roundRect">
+            <a:avLst/>
+          </a:prstGeom>
+          <a:solidFill>
+            <a:srgbClr val="161622"/>
+          </a:solidFill>
+          <a:ln>
+            <a:solidFill>
+              <a:srgbClr val="373748"/>
+            </a:solidFill>
+          </a:ln>
+        </p:spPr>
+        <p:style>
+          <a:lnRef idx="1">
+            <a:schemeClr val="accent1"/>
+          </a:lnRef>
+          <a:fillRef idx="3">
+            <a:schemeClr val="accent1"/>
+          </a:fillRef>
+          <a:effectRef idx="2">
+            <a:schemeClr val="accent1"/>
+          </a:effectRef>
+          <a:fontRef idx="minor">
+            <a:schemeClr val="lt1"/>
+          </a:fontRef>
+        </p:style>
+        <p:txBody>
+          <a:bodyPr rtlCol="0" anchor="ctr" lIns="137160"/>
+          <a:lstStyle/>
+          <a:p>
+            <a:pPr algn="ctr">
+              <a:defRPr sz="1600" b="1">
+                <a:solidFill>
+                  <a:srgbClr val="FFFFFF"/>
+                </a:solidFill>
+              </a:defRPr>
+            </a:pPr>
+            <a:r>
+              <a:t>Split bill (split_bill)</a:t>
+            </a:r>
+          </a:p>
+          <a:p>
+            <a:pPr>
+              <a:spcBef>
+                <a:spcPts val="600"/>
+              </a:spcBef>
+              <a:defRPr sz="1100">
+                <a:solidFill>
+                  <a:srgbClr val="A1A1AA"/>
+                </a:solidFill>
+              </a:defRPr>
+            </a:pPr>
+            <a:r>
+              <a:t>Pay by item, split evenly, partial payments</a:t>
             </a:r>
           </a:p>
         </p:txBody>
       </p:sp>
       <p:pic>
         <p:nvPicPr>
-          <p:cNvPr id="4" name="Picture 3" descr="06-pending-payments.png"/>
+          <p:cNvPr id="7" name="Picture 6" descr="05-table-ordering-panel.png"/>
           <p:cNvPicPr>
             <a:picLocks noChangeAspect="1"/>
           </p:cNvPicPr>
@@ -5904,8 +7810,8 @@
         </p:blipFill>
         <p:spPr>
           <a:xfrm>
-            <a:off x="6217920" y="1097280"/>
-            <a:ext cx="5303520" cy="3314700"/>
+            <a:off x="6217920" y="1371600"/>
+            <a:ext cx="5029200" cy="2560320"/>
           </a:xfrm>
           <a:prstGeom prst="rect">
             <a:avLst/>
@@ -5914,7 +7820,7 @@
       </p:pic>
       <p:sp>
         <p:nvSpPr>
-          <p:cNvPr id="5" name="TextBox 4"/>
+          <p:cNvPr id="8" name="TextBox 7"/>
           <p:cNvSpPr txBox="1"/>
           <p:nvPr/>
         </p:nvSpPr>
@@ -5942,7 +7848,7 @@
               </a:defRPr>
             </a:pPr>
             <a:r>
-              <a:t>TableTap · Smart Restaurant Ordering</a:t>
+              <a:t>TableTap · Complete Restaurant Platform</a:t>
             </a:r>
           </a:p>
         </p:txBody>
@@ -5961,7 +7867,7 @@
     <p:bg>
       <p:bgPr>
         <a:solidFill>
-          <a:srgbClr val="0F0F1A"/>
+          <a:srgbClr val="08080E"/>
         </a:solidFill>
         <a:effectLst/>
       </p:bgPr>
@@ -5975,7 +7881,50 @@
       <p:grpSpPr/>
       <p:sp>
         <p:nvSpPr>
-          <p:cNvPr id="2" name="TextBox 1"/>
+          <p:cNvPr id="2" name="Rectangle 1"/>
+          <p:cNvSpPr/>
+          <p:nvPr/>
+        </p:nvSpPr>
+        <p:spPr>
+          <a:xfrm>
+            <a:off x="0" y="0"/>
+            <a:ext cx="12191695" cy="73152"/>
+          </a:xfrm>
+          <a:prstGeom prst="rect">
+            <a:avLst/>
+          </a:prstGeom>
+          <a:solidFill>
+            <a:srgbClr val="F97316"/>
+          </a:solidFill>
+          <a:ln>
+            <a:noFill/>
+          </a:ln>
+        </p:spPr>
+        <p:style>
+          <a:lnRef idx="1">
+            <a:schemeClr val="accent1"/>
+          </a:lnRef>
+          <a:fillRef idx="3">
+            <a:schemeClr val="accent1"/>
+          </a:fillRef>
+          <a:effectRef idx="2">
+            <a:schemeClr val="accent1"/>
+          </a:effectRef>
+          <a:fontRef idx="minor">
+            <a:schemeClr val="lt1"/>
+          </a:fontRef>
+        </p:style>
+        <p:txBody>
+          <a:bodyPr rtlCol="0" anchor="ctr"/>
+          <a:lstStyle/>
+          <a:p>
+            <a:pPr algn="ctr"/>
+          </a:p>
+        </p:txBody>
+      </p:sp>
+      <p:sp>
+        <p:nvSpPr>
+          <p:cNvPr id="3" name="TextBox 2"/>
           <p:cNvSpPr txBox="1"/>
           <p:nvPr/>
         </p:nvSpPr>
@@ -6003,7 +7952,7 @@
               </a:defRPr>
             </a:pPr>
             <a:r>
-              <a:t>QR codes &amp; PhonePe setup</a:t>
+              <a:t>Payments</a:t>
             </a:r>
           </a:p>
           <a:p>
@@ -6018,21 +7967,21 @@
               </a:defRPr>
             </a:pPr>
             <a:r>
-              <a:t>Owner/Manager admin tools</a:t>
-            </a:r>
-          </a:p>
-        </p:txBody>
-      </p:sp>
-      <p:sp>
-        <p:nvSpPr>
-          <p:cNvPr id="3" name="TextBox 2"/>
+              <a:t>PhonePe QR + staff verification + thermal receipts</a:t>
+            </a:r>
+          </a:p>
+        </p:txBody>
+      </p:sp>
+      <p:sp>
+        <p:nvSpPr>
+          <p:cNvPr id="4" name="TextBox 3"/>
           <p:cNvSpPr txBox="1"/>
           <p:nvPr/>
         </p:nvSpPr>
         <p:spPr>
           <a:xfrm>
             <a:off x="640080" y="1463040"/>
-            <a:ext cx="5029200" cy="4572000"/>
+            <a:ext cx="5303520" cy="4572000"/>
           </a:xfrm>
           <a:prstGeom prst="rect">
             <a:avLst/>
@@ -6047,68 +7996,98 @@
           <a:p>
             <a:pPr>
               <a:spcAft>
-                <a:spcPts val="1000"/>
+                <a:spcPts val="800"/>
               </a:spcAft>
-              <a:defRPr sz="1800">
-                <a:solidFill>
-                  <a:srgbClr val="FFFFFF"/>
-                </a:solidFill>
-              </a:defRPr>
-            </a:pPr>
-            <a:r>
-              <a:t>Print QR codes for every table</a:t>
+              <a:defRPr sz="1700">
+                <a:solidFill>
+                  <a:srgbClr val="FFFFFF"/>
+                </a:solidFill>
+              </a:defRPr>
+            </a:pPr>
+            <a:r>
+              <a:t>Upload PhonePe static QR once in admin</a:t>
             </a:r>
           </a:p>
           <a:p>
             <a:pPr>
               <a:spcAft>
-                <a:spcPts val="1000"/>
+                <a:spcPts val="800"/>
               </a:spcAft>
-              <a:defRPr sz="1800">
-                <a:solidFill>
-                  <a:srgbClr val="FFFFFF"/>
-                </a:solidFill>
-              </a:defRPr>
-            </a:pPr>
-            <a:r>
-              <a:t>Upload PhonePe static QR image from computer</a:t>
+              <a:defRPr sz="1700">
+                <a:solidFill>
+                  <a:srgbClr val="FFFFFF"/>
+                </a:solidFill>
+              </a:defRPr>
+            </a:pPr>
+            <a:r>
+              <a:t>Guest taps Pay → QR on their phone</a:t>
             </a:r>
           </a:p>
           <a:p>
             <a:pPr>
               <a:spcAft>
-                <a:spcPts val="1000"/>
+                <a:spcPts val="800"/>
               </a:spcAft>
-              <a:defRPr sz="1800">
-                <a:solidFill>
-                  <a:srgbClr val="FFFFFF"/>
-                </a:solidFill>
-              </a:defRPr>
-            </a:pPr>
-            <a:r>
-              <a:t>Configure max phones per table (session limit)</a:t>
+              <a:defRPr sz="1700">
+                <a:solidFill>
+                  <a:srgbClr val="FFFFFF"/>
+                </a:solidFill>
+              </a:defRPr>
+            </a:pPr>
+            <a:r>
+              <a:t>Staff marks paid → table unlocks</a:t>
             </a:r>
           </a:p>
           <a:p>
             <a:pPr>
               <a:spcAft>
-                <a:spcPts val="1000"/>
+                <a:spcPts val="800"/>
               </a:spcAft>
-              <a:defRPr sz="1800">
-                <a:solidFill>
-                  <a:srgbClr val="FFFFFF"/>
-                </a:solidFill>
-              </a:defRPr>
-            </a:pPr>
-            <a:r>
-              <a:t>Open/close ordering per table</a:t>
+              <a:defRPr sz="1700">
+                <a:solidFill>
+                  <a:srgbClr val="FFFFFF"/>
+                </a:solidFill>
+              </a:defRPr>
+            </a:pPr>
+            <a:r>
+              <a:t>Revenue reports count only confirmed payments</a:t>
+            </a:r>
+          </a:p>
+          <a:p>
+            <a:pPr>
+              <a:spcAft>
+                <a:spcPts val="800"/>
+              </a:spcAft>
+              <a:defRPr sz="1700">
+                <a:solidFill>
+                  <a:srgbClr val="FFFFFF"/>
+                </a:solidFill>
+              </a:defRPr>
+            </a:pPr>
+            <a:r>
+              <a:t>Bluetooth ESC/POS receipt on full pay (premium)</a:t>
+            </a:r>
+          </a:p>
+          <a:p>
+            <a:pPr>
+              <a:spcAft>
+                <a:spcPts val="800"/>
+              </a:spcAft>
+              <a:defRPr sz="1700">
+                <a:solidFill>
+                  <a:srgbClr val="FFFFFF"/>
+                </a:solidFill>
+              </a:defRPr>
+            </a:pPr>
+            <a:r>
+              <a:t>GSTIN on receipts when gst_receipts enabled</a:t>
             </a:r>
           </a:p>
         </p:txBody>
       </p:sp>
       <p:pic>
         <p:nvPicPr>
-          <p:cNvPr id="4" name="Picture 3" descr="07-admin-qr-codes.png"/>
+          <p:cNvPr id="5" name="Picture 4" descr="06-pending-payments.png"/>
           <p:cNvPicPr>
             <a:picLocks noChangeAspect="1"/>
           </p:cNvPicPr>
@@ -6122,8 +8101,8 @@
         </p:blipFill>
         <p:spPr>
           <a:xfrm>
-            <a:off x="5943600" y="1005840"/>
-            <a:ext cx="5669280" cy="3543300"/>
+            <a:off x="6217920" y="1097280"/>
+            <a:ext cx="5303520" cy="3314700"/>
           </a:xfrm>
           <a:prstGeom prst="rect">
             <a:avLst/>
@@ -6132,7 +8111,7 @@
       </p:pic>
       <p:sp>
         <p:nvSpPr>
-          <p:cNvPr id="5" name="TextBox 4"/>
+          <p:cNvPr id="6" name="TextBox 5"/>
           <p:cNvSpPr txBox="1"/>
           <p:nvPr/>
         </p:nvSpPr>
@@ -6160,7 +8139,7 @@
               </a:defRPr>
             </a:pPr>
             <a:r>
-              <a:t>TableTap · Smart Restaurant Ordering</a:t>
+              <a:t>TableTap · Complete Restaurant Platform</a:t>
             </a:r>
           </a:p>
         </p:txBody>

</xml_diff>